<commit_message>
Thêm seed 1 triệu đơn (seed:big), công cụ đo bench.js, covering index INCLUDE id; cập nhật tiểu luận/slide với số liệu 1M
Co-Authored-By: Claude Fable 5.1 <noreply@anthropic.com>
Claude-Session: https://claude.ai/code/session_01PHEC9JqtDAXfCescD4czfd
</commit_message>
<xml_diff>
--- a/docs/Slide_CSDL_Nhom6_PostgreSQL.pptx
+++ b/docs/Slide_CSDL_Nhom6_PostgreSQL.pptx
@@ -122,7 +122,7 @@
   <p:extLst>
     <p:ext uri="{521415D9-36F7-43E2-AB2F-B90AF26B5E84}">
       <p14:sectionLst xmlns:p14="http://schemas.microsoft.com/office/powerpoint/2010/main">
-        <p14:section name="Mở đầu" id="{72c58e4e-0849-25fd-5232-c00fa3e9411c}">
+        <p14:section name="Mở đầu" id="{26430d00-58ec-c5fe-32b8-0e9997a2927f}">
           <p14:sldIdLst>
             <p14:sldId id="256"/>
             <p14:sldId id="257"/>
@@ -130,13 +130,13 @@
             <p14:sldId id="259"/>
           </p14:sldIdLst>
         </p14:section>
-        <p14:section name="Thiết kế" id="{ed59bb3e-1a72-cf8e-adbf-aa66fc8a9f61}">
+        <p14:section name="Thiết kế" id="{9f1b586f-79dc-dbbc-bd0d-7b5e8daed571}">
           <p14:sldIdLst>
             <p14:sldId id="260"/>
             <p14:sldId id="261"/>
           </p14:sldIdLst>
         </p14:section>
-        <p14:section name="6 tính năng" id="{72ab7be9-7cb2-1f75-838e-bad8b574453a}">
+        <p14:section name="6 tính năng" id="{4ae6b3df-6b7f-e3e2-6cc9-9642b54e48ce}">
           <p14:sldIdLst>
             <p14:sldId id="262"/>
             <p14:sldId id="263"/>
@@ -147,13 +147,13 @@
             <p14:sldId id="268"/>
           </p14:sldIdLst>
         </p14:section>
-        <p14:section name="Ứng dụng &amp; kết quả" id="{ba93907b-2b7d-9a76-b2d2-bcc882405cb7}">
+        <p14:section name="Ứng dụng &amp; kết quả" id="{fee89660-aebe-60b8-c5f9-7b818e578f00}">
           <p14:sldIdLst>
             <p14:sldId id="269"/>
             <p14:sldId id="270"/>
           </p14:sldIdLst>
         </p14:section>
-        <p14:section name="Kết luận" id="{48fa4e8d-6621-dd58-3ac2-c827d64a5a00}">
+        <p14:section name="Kết luận" id="{0eead5ad-caa4-a601-7974-f4b984971f55}">
           <p14:sldIdLst>
             <p14:sldId id="271"/>
           </p14:sldIdLst>
@@ -226,29 +226,32 @@
           </c:dLbls>
           <c:cat>
             <c:multiLvlStrRef>
-              <c:f>Sheet1!$A$2:$A$8</c:f>
+              <c:f>Sheet1!$A$2:$A$9</c:f>
               <c:multiLvlStrCache>
-                <c:ptCount val="7"/>
+                <c:ptCount val="8"/>
                 <c:lvl>
                   <c:pt idx="0">
                     <c:v>Materialized view</c:v>
                   </c:pt>
                   <c:pt idx="1">
-                    <c:v>JSONB @&gt; (GIN)</c:v>
+                    <c:v>Partial index</c:v>
                   </c:pt>
                   <c:pt idx="2">
-                    <c:v>Partial index</c:v>
+                    <c:v>Covering index</c:v>
                   </c:pt>
                   <c:pt idx="3">
-                    <c:v>Full-text (GIN)</c:v>
+                    <c:v>JSONB @&gt; (GIN)</c:v>
                   </c:pt>
                   <c:pt idx="4">
                     <c:v>Partition pruning</c:v>
                   </c:pt>
                   <c:pt idx="5">
+                    <c:v>Full-text (GIN)</c:v>
+                  </c:pt>
+                  <c:pt idx="6">
                     <c:v>pgvector HNSW</c:v>
                   </c:pt>
-                  <c:pt idx="6">
+                  <c:pt idx="7">
                     <c:v>Trigram</c:v>
                   </c:pt>
                 </c:lvl>
@@ -257,30 +260,33 @@
           </c:cat>
           <c:val>
             <c:numRef>
-              <c:f>Sheet1!$B$2:$B$8</c:f>
+              <c:f>Sheet1!$B$2:$B$9</c:f>
               <c:numCache>
                 <c:formatCode>General</c:formatCode>
-                <c:ptCount val="7"/>
+                <c:ptCount val="8"/>
                 <c:pt idx="0">
-                  <c:v>150</c:v>
+                  <c:v>1077</c:v>
                 </c:pt>
                 <c:pt idx="1">
-                  <c:v>28</c:v>
+                  <c:v>484</c:v>
                 </c:pt>
                 <c:pt idx="2">
-                  <c:v>16</c:v>
+                  <c:v>251</c:v>
                 </c:pt>
                 <c:pt idx="3">
-                  <c:v>7</c:v>
+                  <c:v>34</c:v>
                 </c:pt>
                 <c:pt idx="4">
-                  <c:v>5.9</c:v>
+                  <c:v>20</c:v>
                 </c:pt>
                 <c:pt idx="5">
-                  <c:v>5.6</c:v>
+                  <c:v>9.6</c:v>
                 </c:pt>
                 <c:pt idx="6">
-                  <c:v>2.5</c:v>
+                  <c:v>7.4</c:v>
+                </c:pt>
+                <c:pt idx="7">
+                  <c:v>2.6</c:v>
                 </c:pt>
               </c:numCache>
             </c:numRef>
@@ -360,6 +366,7 @@
       <c:valAx>
         <c:axId val="2094734552"/>
         <c:scaling>
+          <c:logBase val="10"/>
           <c:orientation val="minMax"/>
         </c:scaling>
         <c:delete val="1"/>
@@ -3420,7 +3427,7 @@
                 <a:ea typeface="Arial" pitchFamily="34" charset="-122"/>
                 <a:cs typeface="Arial" pitchFamily="34" charset="-120"/>
               </a:rPr>
-              <a:t>1 / 13</a:t>
+              <a:t>1 / 37</a:t>
             </a:r>
             <a:endParaRPr lang="en-US" sz="3200" dirty="0"/>
           </a:p>
@@ -3476,7 +3483,7 @@
                 <a:ea typeface="Arial" pitchFamily="34" charset="-122"/>
                 <a:cs typeface="Arial" pitchFamily="34" charset="-120"/>
               </a:rPr>
-              <a:t>nhờ partition pruning</a:t>
+              <a:t>(1 triệu đơn) nhờ pruning</a:t>
             </a:r>
             <a:endParaRPr lang="en-US" sz="1200" dirty="0"/>
           </a:p>
@@ -3540,7 +3547,7 @@
                 <a:ea typeface="Arial" pitchFamily="34" charset="-122"/>
                 <a:cs typeface="Arial" pitchFamily="34" charset="-120"/>
               </a:rPr>
-              <a:t>312 kB</a:t>
+              <a:t>888 kB</a:t>
             </a:r>
             <a:endParaRPr lang="en-US" sz="3200" dirty="0"/>
           </a:p>
@@ -3579,7 +3586,7 @@
                 <a:ea typeface="Arial" pitchFamily="34" charset="-122"/>
                 <a:cs typeface="Arial" pitchFamily="34" charset="-120"/>
               </a:rPr>
-              <a:t>BRIN so với 1.000 kB</a:t>
+              <a:t>BRIN so với 23 MB</a:t>
             </a:r>
             <a:endParaRPr lang="en-US" sz="1200" dirty="0"/>
           </a:p>
@@ -3596,7 +3603,7 @@
                 <a:ea typeface="Arial" pitchFamily="34" charset="-122"/>
                 <a:cs typeface="Arial" pitchFamily="34" charset="-120"/>
               </a:rPr>
-              <a:t>B-tree cùng cột</a:t>
+              <a:t>B-tree cùng cột (26×)</a:t>
             </a:r>
             <a:endParaRPr lang="en-US" sz="1200" dirty="0"/>
           </a:p>
@@ -3662,7 +3669,7 @@
                 <a:ea typeface="Arial" pitchFamily="34" charset="-122"/>
                 <a:cs typeface="Arial" pitchFamily="34" charset="-120"/>
               </a:rPr>
-              <a:t>Báo cáo theo khoảng ngày: 0,29 ms so với 1,68 ms</a:t>
+              <a:t>Doanh thu 2 tuần: 3,3 ms so với 66 ms (20×)</a:t>
             </a:r>
             <a:endParaRPr lang="en-US" sz="1300" dirty="0"/>
           </a:p>
@@ -4310,7 +4317,7 @@
                 <a:ea typeface="Arial" pitchFamily="34" charset="-122"/>
                 <a:cs typeface="Arial" pitchFamily="34" charset="-120"/>
               </a:rPr>
-              <a:t>625</a:t>
+              <a:t>1.090</a:t>
             </a:r>
             <a:endParaRPr lang="en-US" sz="3200" dirty="0"/>
           </a:p>
@@ -4366,7 +4373,7 @@
                 <a:ea typeface="Arial" pitchFamily="34" charset="-122"/>
                 <a:cs typeface="Arial" pitchFamily="34" charset="-120"/>
               </a:rPr>
-              <a:t>(pgbench, máy ảo 2 vCPU)</a:t>
+              <a:t>trên CSDL 1 triệu đơn</a:t>
             </a:r>
             <a:endParaRPr lang="en-US" sz="1200" dirty="0"/>
           </a:p>
@@ -4739,7 +4746,7 @@
                 <a:ea typeface="Arial" pitchFamily="34" charset="-122"/>
                 <a:cs typeface="Arial" pitchFamily="34" charset="-120"/>
               </a:rPr>
-              <a:t>150×</a:t>
+              <a:t>1.000×</a:t>
             </a:r>
             <a:endParaRPr lang="en-US" sz="3200" dirty="0"/>
           </a:p>
@@ -4778,7 +4785,7 @@
                 <a:ea typeface="Arial" pitchFamily="34" charset="-122"/>
                 <a:cs typeface="Arial" pitchFamily="34" charset="-120"/>
               </a:rPr>
-              <a:t>doanh thu 30 ngày: 0,012 ms</a:t>
+              <a:t>doanh thu 30 ngày: 0,018 ms</a:t>
             </a:r>
             <a:endParaRPr lang="en-US" sz="1200" dirty="0"/>
           </a:p>
@@ -4795,7 +4802,7 @@
                 <a:ea typeface="Arial" pitchFamily="34" charset="-122"/>
                 <a:cs typeface="Arial" pitchFamily="34" charset="-120"/>
               </a:rPr>
-              <a:t>so với 1,8 ms tính trực tiếp</a:t>
+              <a:t>so với 19 ms tính trực tiếp</a:t>
             </a:r>
             <a:endParaRPr lang="en-US" sz="1200" dirty="0"/>
           </a:p>
@@ -5441,7 +5448,7 @@
                           <a:ea typeface="Courier New" pitchFamily="34" charset="-122"/>
                           <a:cs typeface="Courier New" pitchFamily="34" charset="-120"/>
                         </a:rPr>
-                        <a:t>products (stock, id) WHERE stock &lt; 3</a:t>
+                        <a:t>orders (created_at) WHERE status IN (pending, confirmed)</a:t>
                       </a:r>
                       <a:endParaRPr lang="en-US" sz="1200" dirty="0">
                         <a:latin typeface="Courier New" charset="0"/>
@@ -5509,7 +5516,7 @@
                           <a:ea typeface="Arial" pitchFamily="34" charset="-122"/>
                           <a:cs typeface="Arial" pitchFamily="34" charset="-120"/>
                         </a:rPr>
-                        <a:t>40 kB thay vì 168 kB; 16×</a:t>
+                        <a:t>0,2 ms so với 98 ms trên 1 triệu đơn (480×)</a:t>
                       </a:r>
                       <a:endParaRPr lang="en-US" sz="1400" dirty="0">
                         <a:latin typeface="Arial" charset="0"/>
@@ -5647,7 +5654,7 @@
                           <a:ea typeface="Courier New" pitchFamily="34" charset="-122"/>
                           <a:cs typeface="Courier New" pitchFamily="34" charset="-120"/>
                         </a:rPr>
-                        <a:t>orders (customer_id, created_at) INCLUDE (status, total)</a:t>
+                        <a:t>orders (customer_id, created_at) INCLUDE (id, status, total)</a:t>
                       </a:r>
                       <a:endParaRPr lang="en-US" sz="1200" dirty="0">
                         <a:latin typeface="Courier New" charset="0"/>
@@ -5715,7 +5722,7 @@
                           <a:ea typeface="Arial" pitchFamily="34" charset="-122"/>
                           <a:cs typeface="Arial" pitchFamily="34" charset="-120"/>
                         </a:rPr>
-                        <a:t>Index Only Scan, Heap Fetches = 0</a:t>
+                        <a:t>Index Only Scan, Heap Fetches = 0; 250×</a:t>
                       </a:r>
                       <a:endParaRPr lang="en-US" sz="1400" dirty="0">
                         <a:latin typeface="Arial" charset="0"/>
@@ -6354,7 +6361,7 @@
                           <a:ea typeface="Arial" pitchFamily="34" charset="-122"/>
                           <a:cs typeface="Arial" pitchFamily="34" charset="-120"/>
                         </a:rPr>
-                        <a:t>2,5× – 28× so với quét tuần tự</a:t>
+                        <a:t>2,6× – 34× so với quét tuần tự</a:t>
                       </a:r>
                       <a:endParaRPr lang="en-US" sz="1400" dirty="0">
                         <a:latin typeface="Arial" charset="0"/>
@@ -6902,7 +6909,7 @@
                 <a:ea typeface="Arial" pitchFamily="34" charset="-122"/>
                 <a:cs typeface="Arial" pitchFamily="34" charset="-120"/>
               </a:rPr>
-              <a:t>1.690</a:t>
+              <a:t>1 triệu</a:t>
             </a:r>
             <a:endParaRPr lang="en-US" sz="3200" dirty="0"/>
           </a:p>
@@ -6941,7 +6948,7 @@
                 <a:ea typeface="Arial" pitchFamily="34" charset="-122"/>
                 <a:cs typeface="Arial" pitchFamily="34" charset="-120"/>
               </a:rPr>
-              <a:t>truy vấn đọc / giây</a:t>
+              <a:t>đơn hàng / 37 partition</a:t>
             </a:r>
             <a:endParaRPr lang="en-US" sz="1200" dirty="0"/>
           </a:p>
@@ -6958,7 +6965,7 @@
                 <a:ea typeface="Arial" pitchFamily="34" charset="-122"/>
                 <a:cs typeface="Arial" pitchFamily="34" charset="-120"/>
               </a:rPr>
-              <a:t>(FTS + JSONB + vector)</a:t>
+              <a:t>npm run seed:big</a:t>
             </a:r>
             <a:endParaRPr lang="en-US" sz="1200" dirty="0"/>
           </a:p>
@@ -7022,7 +7029,7 @@
                 <a:ea typeface="Arial" pitchFamily="34" charset="-122"/>
                 <a:cs typeface="Arial" pitchFamily="34" charset="-120"/>
               </a:rPr>
-              <a:t>625</a:t>
+              <a:t>1.090</a:t>
             </a:r>
             <a:endParaRPr lang="en-US" sz="3200" dirty="0"/>
           </a:p>
@@ -7121,7 +7128,7 @@
                 <a:ea typeface="Arial" pitchFamily="34" charset="-122"/>
                 <a:cs typeface="Arial" pitchFamily="34" charset="-120"/>
               </a:rPr>
-              <a:t>Giám sát: pg_stat_statements, pg_stat_user_indexes, Grafana</a:t>
+              <a:t>Tool đo npm run bench: 12 kịch bản × 5 lần, lấy trung vị, xuất Markdown/JSON</a:t>
             </a:r>
             <a:endParaRPr lang="en-US" sz="1300" dirty="0"/>
           </a:p>
@@ -7142,7 +7149,7 @@
                 <a:ea typeface="Arial" pitchFamily="34" charset="-122"/>
                 <a:cs typeface="Arial" pitchFamily="34" charset="-120"/>
               </a:rPr>
-              <a:t>Dữ liệu: 3.033 sản phẩm, 35.000 đơn, PostgreSQL 16</a:t>
+              <a:t>Giám sát: pg_stat_statements, Grafana</a:t>
             </a:r>
             <a:endParaRPr lang="en-US" sz="1300" dirty="0"/>
           </a:p>
@@ -7320,7 +7327,7 @@
                 <a:ea typeface="Arial" pitchFamily="34" charset="-122"/>
                 <a:cs typeface="Arial" pitchFamily="34" charset="-120"/>
               </a:rPr>
-              <a:t>6 tính năng gắn 6 nghiệp vụ, đều có số đo: nhanh hơn 2,5× – 150×; 50 client đồng thời không bán quá kho</a:t>
+              <a:t>6 tính năng gắn 6 nghiệp vụ, đo trên 1 triệu đơn: nhanh hơn 2,6× – 1.000×; 50 client đồng thời không bán quá kho</a:t>
             </a:r>
             <a:endParaRPr lang="en-US" sz="1800" dirty="0"/>
           </a:p>
@@ -7341,7 +7348,7 @@
                 <a:ea typeface="Arial" pitchFamily="34" charset="-122"/>
                 <a:cs typeface="Arial" pitchFamily="34" charset="-120"/>
               </a:rPr>
-              <a:t>Hạn chế: embedding feature hashing, chưa có từ điển tiếng Việt, dữ liệu thử nghiệm vài chục nghìn dòng</a:t>
+              <a:t>Hạn chế: embedding feature hashing, chưa có từ điển tiếng Việt, chưa tinh chỉnh tham số PostgreSQL</a:t>
             </a:r>
             <a:endParaRPr lang="en-US" sz="1800" dirty="0"/>
           </a:p>
@@ -10429,7 +10436,7 @@
                 <a:ea typeface="Arial" pitchFamily="34" charset="-122"/>
                 <a:cs typeface="Arial" pitchFamily="34" charset="-120"/>
               </a:rPr>
-              <a:t>docker compose up → db + api + web + Grafana; dữ liệu mẫu 3.033 sản phẩm, 30.000 đơn</a:t>
+              <a:t>docker compose up → db + api + web + Grafana; npm run seed:big → 1 triệu đơn, npm run bench → báo cáo đo</a:t>
             </a:r>
             <a:endParaRPr lang="en-US" sz="1700" dirty="0"/>
           </a:p>
@@ -11029,7 +11036,7 @@
                 <a:ea typeface="Arial" pitchFamily="34" charset="-122"/>
                 <a:cs typeface="Arial" pitchFamily="34" charset="-120"/>
               </a:rPr>
-              <a:t>28×</a:t>
+              <a:t>34×</a:t>
             </a:r>
             <a:endParaRPr lang="en-US" sz="3200" dirty="0"/>
           </a:p>
@@ -11085,7 +11092,7 @@
                 <a:ea typeface="Arial" pitchFamily="34" charset="-122"/>
                 <a:cs typeface="Arial" pitchFamily="34" charset="-120"/>
               </a:rPr>
-              <a:t>0,056 ms so với 1,57 ms</a:t>
+              <a:t>0,06 ms so với 2,1 ms</a:t>
             </a:r>
             <a:endParaRPr lang="en-US" sz="1200" dirty="0"/>
           </a:p>
@@ -11678,7 +11685,7 @@
                 <a:ea typeface="Arial" pitchFamily="34" charset="-122"/>
                 <a:cs typeface="Arial" pitchFamily="34" charset="-120"/>
               </a:rPr>
-              <a:t>7×</a:t>
+              <a:t>9,6×</a:t>
             </a:r>
             <a:endParaRPr lang="en-US" sz="3200" dirty="0"/>
           </a:p>
@@ -12281,7 +12288,7 @@
                 <a:ea typeface="Arial" pitchFamily="34" charset="-122"/>
                 <a:cs typeface="Arial" pitchFamily="34" charset="-120"/>
               </a:rPr>
-              <a:t>HNSW: 0,25 ms so với 1,43 ms khi tính khoảng cách cho toàn bộ 3.033 vector (5,6×)</a:t>
+              <a:t>HNSW: 0,23 ms so với 1,7 ms khi tính khoảng cách cho toàn bộ 3.033 vector (7,4×)</a:t>
             </a:r>
             <a:endParaRPr lang="en-US" sz="1400" dirty="0"/>
           </a:p>

</xml_diff>

<commit_message>
Bỏ Grafana: giám sát bằng trang Monitor trong admin + bench.js; compose còn 3 service
Co-Authored-By: Claude Fable 5.1 <noreply@anthropic.com>
Claude-Session: https://claude.ai/code/session_01PHEC9JqtDAXfCescD4czfd
</commit_message>
<xml_diff>
--- a/docs/Slide_CSDL_Nhom6_PostgreSQL.pptx
+++ b/docs/Slide_CSDL_Nhom6_PostgreSQL.pptx
@@ -122,7 +122,7 @@
   <p:extLst>
     <p:ext uri="{521415D9-36F7-43E2-AB2F-B90AF26B5E84}">
       <p14:sectionLst xmlns:p14="http://schemas.microsoft.com/office/powerpoint/2010/main">
-        <p14:section name="Mở đầu" id="{26430d00-58ec-c5fe-32b8-0e9997a2927f}">
+        <p14:section name="Mở đầu" id="{962c63bf-a760-10f2-833b-41f1e5c0bc21}">
           <p14:sldIdLst>
             <p14:sldId id="256"/>
             <p14:sldId id="257"/>
@@ -130,13 +130,13 @@
             <p14:sldId id="259"/>
           </p14:sldIdLst>
         </p14:section>
-        <p14:section name="Thiết kế" id="{9f1b586f-79dc-dbbc-bd0d-7b5e8daed571}">
+        <p14:section name="Thiết kế" id="{4461e048-ad3d-8ba0-83a9-9f06785663d9}">
           <p14:sldIdLst>
             <p14:sldId id="260"/>
             <p14:sldId id="261"/>
           </p14:sldIdLst>
         </p14:section>
-        <p14:section name="6 tính năng" id="{4ae6b3df-6b7f-e3e2-6cc9-9642b54e48ce}">
+        <p14:section name="6 tính năng" id="{2c32b78b-a20e-b54e-9bb4-96daa42ce86c}">
           <p14:sldIdLst>
             <p14:sldId id="262"/>
             <p14:sldId id="263"/>
@@ -147,13 +147,13 @@
             <p14:sldId id="268"/>
           </p14:sldIdLst>
         </p14:section>
-        <p14:section name="Ứng dụng &amp; kết quả" id="{fee89660-aebe-60b8-c5f9-7b818e578f00}">
+        <p14:section name="Ứng dụng &amp; kết quả" id="{7beeb413-7d5f-1776-1736-66da5a7df9d4}">
           <p14:sldIdLst>
             <p14:sldId id="269"/>
             <p14:sldId id="270"/>
           </p14:sldIdLst>
         </p14:section>
-        <p14:section name="Kết luận" id="{0eead5ad-caa4-a601-7974-f4b984971f55}">
+        <p14:section name="Kết luận" id="{8f72526f-e359-9eae-6884-94fa1b93362c}">
           <p14:sldIdLst>
             <p14:sldId id="271"/>
           </p14:sldIdLst>
@@ -7149,7 +7149,7 @@
                 <a:ea typeface="Arial" pitchFamily="34" charset="-122"/>
                 <a:cs typeface="Arial" pitchFamily="34" charset="-120"/>
               </a:rPr>
-              <a:t>Giám sát: pg_stat_statements, Grafana</a:t>
+              <a:t>Giám sát: pg_stat_statements, trang Monitor trong admin</a:t>
             </a:r>
             <a:endParaRPr lang="en-US" sz="1300" dirty="0"/>
           </a:p>
@@ -10436,7 +10436,7 @@
                 <a:ea typeface="Arial" pitchFamily="34" charset="-122"/>
                 <a:cs typeface="Arial" pitchFamily="34" charset="-120"/>
               </a:rPr>
-              <a:t>docker compose up → db + api + web + Grafana; npm run seed:big → 1 triệu đơn, npm run bench → báo cáo đo</a:t>
+              <a:t>docker compose up → db + api + web; npm run seed:big → 1 triệu đơn, npm run bench → báo cáo đo</a:t>
             </a:r>
             <a:endParaRPr lang="en-US" sz="1700" dirty="0"/>
           </a:p>

</xml_diff>

<commit_message>
Slide: thêm trang Demo DBeaver
Co-Authored-By: Claude Fable 5.1 <noreply@anthropic.com>
Claude-Session: https://claude.ai/code/session_01PHEC9JqtDAXfCescD4czfd
</commit_message>
<xml_diff>
--- a/docs/Slide_CSDL_Nhom6_PostgreSQL.pptx
+++ b/docs/Slide_CSDL_Nhom6_PostgreSQL.pptx
@@ -21,9 +21,10 @@
     <p:sldId id="269" r:id="rId15"/>
     <p:sldId id="270" r:id="rId16"/>
     <p:sldId id="271" r:id="rId17"/>
+    <p:sldId id="272" r:id="rId18"/>
   </p:sldIdLst>
   <p:notesMasterIdLst>
-    <p:notesMasterId r:id="rId18"/>
+    <p:notesMasterId r:id="rId19"/>
   </p:notesMasterIdLst>
   <p:sldSz cx="9144000" cy="6858000"/>
   <p:notesSz cx="6858000" cy="9144000"/>
@@ -122,7 +123,7 @@
   <p:extLst>
     <p:ext uri="{521415D9-36F7-43E2-AB2F-B90AF26B5E84}">
       <p14:sectionLst xmlns:p14="http://schemas.microsoft.com/office/powerpoint/2010/main">
-        <p14:section name="Mở đầu" id="{962c63bf-a760-10f2-833b-41f1e5c0bc21}">
+        <p14:section name="Mở đầu" id="{b578b7eb-1fd2-1a2c-f1d0-61f17d20c5a0}">
           <p14:sldIdLst>
             <p14:sldId id="256"/>
             <p14:sldId id="257"/>
@@ -130,13 +131,13 @@
             <p14:sldId id="259"/>
           </p14:sldIdLst>
         </p14:section>
-        <p14:section name="Thiết kế" id="{4461e048-ad3d-8ba0-83a9-9f06785663d9}">
+        <p14:section name="Thiết kế" id="{2f2e1919-bdc9-9bd3-b7f9-a6cd4fc1c9c2}">
           <p14:sldIdLst>
             <p14:sldId id="260"/>
             <p14:sldId id="261"/>
           </p14:sldIdLst>
         </p14:section>
-        <p14:section name="6 tính năng" id="{2c32b78b-a20e-b54e-9bb4-96daa42ce86c}">
+        <p14:section name="6 tính năng" id="{b477f6ed-f301-c0d1-f989-9a1682f71dc4}">
           <p14:sldIdLst>
             <p14:sldId id="262"/>
             <p14:sldId id="263"/>
@@ -147,15 +148,16 @@
             <p14:sldId id="268"/>
           </p14:sldIdLst>
         </p14:section>
-        <p14:section name="Ứng dụng &amp; kết quả" id="{7beeb413-7d5f-1776-1736-66da5a7df9d4}">
+        <p14:section name="Ứng dụng &amp; kết quả" id="{8da953ea-cdc0-11b2-c860-a13241a4115e}">
           <p14:sldIdLst>
             <p14:sldId id="269"/>
             <p14:sldId id="270"/>
+            <p14:sldId id="271"/>
           </p14:sldIdLst>
         </p14:section>
-        <p14:section name="Kết luận" id="{8f72526f-e359-9eae-6884-94fa1b93362c}">
+        <p14:section name="Kết luận" id="{64ddcb45-1e93-4b01-eef6-ff6fd9454c1f}">
           <p14:sldIdLst>
-            <p14:sldId id="271"/>
+            <p14:sldId id="272"/>
           </p14:sldIdLst>
         </p14:section>
       </p14:sectionLst>
@@ -1473,6 +1475,94 @@
             <a:fld id="{F7021451-1387-4CA6-816F-3879F97B5CBC}" type="slidenum">
               <a:rPr lang="en-US"/>
               <a:t>16</a:t>
+            </a:fld>
+            <a:endParaRPr lang="en-US"/>
+          </a:p>
+        </p:txBody>
+      </p:sp>
+    </p:spTree>
+    <p:extLst>
+      <p:ext uri="{BB962C8B-B14F-4D97-AF65-F5344CB8AC3E}">
+        <p14:creationId xmlns:p14="http://schemas.microsoft.com/office/powerpoint/2010/main" val="1024086991"/>
+      </p:ext>
+    </p:extLst>
+  </p:cSld>
+  <p:clrMapOvr>
+    <a:masterClrMapping/>
+  </p:clrMapOvr>
+</p:notes>
+</file>
+
+<file path=ppt/notesSlides/notesSlide17.xml><?xml version="1.0" encoding="utf-8"?>
+<p:notes xmlns:a="http://schemas.openxmlformats.org/drawingml/2006/main" xmlns:r="http://schemas.openxmlformats.org/officeDocument/2006/relationships" xmlns:p="http://schemas.openxmlformats.org/presentationml/2006/main">
+  <p:cSld>
+    <p:spTree>
+      <p:nvGrpSpPr>
+        <p:cNvPr id="1" name=""/>
+        <p:cNvGrpSpPr/>
+        <p:nvPr/>
+      </p:nvGrpSpPr>
+      <p:grpSpPr>
+        <a:xfrm>
+          <a:off x="0" y="0"/>
+          <a:ext cx="0" cy="0"/>
+          <a:chOff x="0" y="0"/>
+          <a:chExt cx="0" cy="0"/>
+        </a:xfrm>
+      </p:grpSpPr>
+      <p:sp>
+        <p:nvSpPr>
+          <p:cNvPr id="2" name="Slide Image Placeholder 1"/>
+          <p:cNvSpPr>
+            <a:spLocks noGrp="1" noRot="1" noChangeAspect="1"/>
+          </p:cNvSpPr>
+          <p:nvPr>
+            <p:ph type="sldImg"/>
+          </p:nvPr>
+        </p:nvSpPr>
+        <p:spPr/>
+      </p:sp>
+      <p:sp>
+        <p:nvSpPr>
+          <p:cNvPr id="3" name="Notes Placeholder 2"/>
+          <p:cNvSpPr>
+            <a:spLocks noGrp="1"/>
+          </p:cNvSpPr>
+          <p:nvPr>
+            <p:ph type="body" idx="1"/>
+          </p:nvPr>
+        </p:nvSpPr>
+        <p:spPr/>
+        <p:txBody>
+          <a:bodyPr/>
+          <a:lstStyle/>
+          <a:p>
+            <a:r>
+              <a:rPr lang="en-US" dirty="0"/>
+              <a:t/>
+            </a:r>
+            <a:endParaRPr lang="en-US" dirty="0"/>
+          </a:p>
+        </p:txBody>
+      </p:sp>
+      <p:sp>
+        <p:nvSpPr>
+          <p:cNvPr id="4" name="Slide Number Placeholder 3"/>
+          <p:cNvSpPr>
+            <a:spLocks noGrp="1"/>
+          </p:cNvSpPr>
+          <p:nvPr>
+            <p:ph type="sldNum" sz="quarter" idx="10"/>
+          </p:nvPr>
+        </p:nvSpPr>
+        <p:spPr/>
+        <p:txBody>
+          <a:bodyPr/>
+          <a:lstStyle/>
+          <a:p>
+            <a:fld id="{F7021451-1387-4CA6-816F-3879F97B5CBC}" type="slidenum">
+              <a:rPr lang="en-US"/>
+              <a:t>17</a:t>
             </a:fld>
             <a:endParaRPr lang="en-US"/>
           </a:p>
@@ -6829,63 +6919,81 @@
                 <a:ea typeface="Trebuchet MS" pitchFamily="34" charset="-122"/>
                 <a:cs typeface="Trebuchet MS" pitchFamily="34" charset="-120"/>
               </a:rPr>
-              <a:t>Benchmark: có index nhanh hơn bao nhiêu?</a:t>
+              <a:t>Demo trực tiếp bằng DBeaver</a:t>
             </a:r>
             <a:endParaRPr lang="en-US" sz="2800" dirty="0"/>
           </a:p>
         </p:txBody>
       </p:sp>
-      <p:graphicFrame>
-        <p:nvGraphicFramePr>
-          <p:cNvPr id="3" name="speedup-chart" descr=""/>
-          <p:cNvGraphicFramePr/>
-          <p:nvPr/>
-        </p:nvGraphicFramePr>
-        <p:xfrm>
-          <a:off x="731520" y="1371600"/>
-          <a:ext cx="5212080" cy="4937760"/>
-        </p:xfrm>
-        <a:graphic xmlns:a="http://schemas.openxmlformats.org/drawingml/2006/main">
-          <a:graphicData uri="http://schemas.openxmlformats.org/drawingml/2006/chart">
-            <c:chart xmlns:c="http://schemas.openxmlformats.org/drawingml/2006/chart" r:id="rId1"/>
-          </a:graphicData>
-        </a:graphic>
-      </p:graphicFrame>
-      <p:sp>
-        <p:nvSpPr>
-          <p:cNvPr id="4" name="stat-bg"/>
+      <p:sp>
+        <p:nvSpPr>
+          <p:cNvPr id="3" name="pill"/>
           <p:cNvSpPr/>
           <p:nvPr/>
         </p:nvSpPr>
         <p:spPr>
           <a:xfrm>
-            <a:off x="6126480" y="1417320"/>
-            <a:ext cx="2743200" cy="1325880"/>
-          </a:xfrm>
-          <a:prstGeom prst="rect">
-            <a:avLst/>
+            <a:off x="731520" y="1463040"/>
+            <a:ext cx="8138160" cy="502920"/>
+          </a:xfrm>
+          <a:prstGeom prst="roundRect">
+            <a:avLst>
+              <a:gd name="adj" fmla="val 21818"/>
+            </a:avLst>
           </a:prstGeom>
           <a:solidFill>
-            <a:srgbClr val="EEF0FA"/>
+            <a:srgbClr val="FFFFFF"/>
           </a:solidFill>
           <a:ln w="12700">
             <a:solidFill>
-              <a:srgbClr val="EEF0FA"/>
+              <a:srgbClr val="2A10B4"/>
             </a:solidFill>
             <a:prstDash val="solid"/>
           </a:ln>
-        </p:spPr>
-      </p:sp>
-      <p:sp>
-        <p:nvSpPr>
-          <p:cNvPr id="5" name="stat-num"/>
+          <a:effectLst>
+            <a:outerShdw sx="100000" sy="100000" kx="0" ky="0" algn="bl" rotWithShape="0" blurRad="38100" dist="25400" dir="2700000">
+              <a:srgbClr val="000000">
+                <a:alpha val="25000"/>
+              </a:srgbClr>
+            </a:outerShdw>
+          </a:effectLst>
+        </p:spPr>
+      </p:sp>
+      <p:sp>
+        <p:nvSpPr>
+          <p:cNvPr id="4" name="pill-dot"/>
+          <p:cNvSpPr/>
+          <p:nvPr/>
+        </p:nvSpPr>
+        <p:spPr>
+          <a:xfrm>
+            <a:off x="822960" y="1536192"/>
+            <a:ext cx="356616" cy="356616"/>
+          </a:xfrm>
+          <a:prstGeom prst="ellipse">
+            <a:avLst/>
+          </a:prstGeom>
+          <a:solidFill>
+            <a:srgbClr val="2A10B4"/>
+          </a:solidFill>
+          <a:ln w="12700">
+            <a:solidFill>
+              <a:srgbClr val="2A10B4"/>
+            </a:solidFill>
+            <a:prstDash val="solid"/>
+          </a:ln>
+        </p:spPr>
+      </p:sp>
+      <p:sp>
+        <p:nvSpPr>
+          <p:cNvPr id="5" name="Text 3"/>
           <p:cNvSpPr txBox="1"/>
           <p:nvPr/>
         </p:nvSpPr>
         <p:spPr>
           <a:xfrm>
-            <a:off x="6126480" y="1490472"/>
-            <a:ext cx="2743200" cy="685800"/>
+            <a:off x="822960" y="1536192"/>
+            <a:ext cx="356616" cy="356616"/>
           </a:xfrm>
           <a:prstGeom prst="rect">
             <a:avLst/>
@@ -6901,30 +7009,30 @@
               <a:buNone/>
             </a:pPr>
             <a:r>
-              <a:rPr lang="en-US" sz="3200" b="1" dirty="0">
-                <a:solidFill>
-                  <a:srgbClr val="1E8E3E"/>
+              <a:rPr lang="en-US" sz="1300" b="1" dirty="0">
+                <a:solidFill>
+                  <a:srgbClr val="FFFFFF"/>
                 </a:solidFill>
                 <a:latin typeface="Arial" pitchFamily="34" charset="0"/>
                 <a:ea typeface="Arial" pitchFamily="34" charset="-122"/>
                 <a:cs typeface="Arial" pitchFamily="34" charset="-120"/>
               </a:rPr>
-              <a:t>1 triệu</a:t>
-            </a:r>
-            <a:endParaRPr lang="en-US" sz="3200" dirty="0"/>
-          </a:p>
-        </p:txBody>
-      </p:sp>
-      <p:sp>
-        <p:nvSpPr>
-          <p:cNvPr id="6" name="stat-label"/>
+              <a:t>1</a:t>
+            </a:r>
+            <a:endParaRPr lang="en-US" sz="1300" dirty="0"/>
+          </a:p>
+        </p:txBody>
+      </p:sp>
+      <p:sp>
+        <p:nvSpPr>
+          <p:cNvPr id="6" name="Text 4"/>
           <p:cNvSpPr txBox="1"/>
           <p:nvPr/>
         </p:nvSpPr>
         <p:spPr>
           <a:xfrm>
-            <a:off x="6217920" y="2194560"/>
-            <a:ext cx="2560320" cy="502920"/>
+            <a:off x="1280160" y="1463040"/>
+            <a:ext cx="7498080" cy="502920"/>
           </a:xfrm>
           <a:prstGeom prst="rect">
             <a:avLst/>
@@ -6933,79 +7041,233 @@
           <a:ln/>
         </p:spPr>
         <p:txBody>
-          <a:bodyPr wrap="square" lIns="0" tIns="0" rIns="0" bIns="0" rtlCol="0" anchor="t"/>
+          <a:bodyPr wrap="square" lIns="0" tIns="0" rIns="0" bIns="0" rtlCol="0" anchor="ctr"/>
           <a:lstStyle/>
           <a:p>
-            <a:pPr algn="ctr" indent="0" marL="0">
-              <a:buNone/>
-            </a:pPr>
-            <a:r>
-              <a:rPr lang="en-US" sz="1200" dirty="0">
-                <a:solidFill>
-                  <a:srgbClr val="333333"/>
+            <a:pPr indent="0" marL="0">
+              <a:buNone/>
+            </a:pPr>
+            <a:r>
+              <a:rPr lang="en-US" sz="1500" dirty="0">
+                <a:solidFill>
+                  <a:srgbClr val="1A1A1A"/>
                 </a:solidFill>
                 <a:latin typeface="Arial" pitchFamily="34" charset="0"/>
                 <a:ea typeface="Arial" pitchFamily="34" charset="-122"/>
                 <a:cs typeface="Arial" pitchFamily="34" charset="-120"/>
               </a:rPr>
-              <a:t>đơn hàng / 37 partition</a:t>
-            </a:r>
-            <a:endParaRPr lang="en-US" sz="1200" dirty="0"/>
-          </a:p>
+              <a:t>JSONB: lọc attributes @&gt; {metal, stone} → GIN index</a:t>
+            </a:r>
+            <a:endParaRPr lang="en-US" sz="1500" dirty="0"/>
+          </a:p>
+        </p:txBody>
+      </p:sp>
+      <p:sp>
+        <p:nvSpPr>
+          <p:cNvPr id="7" name="pill"/>
+          <p:cNvSpPr/>
+          <p:nvPr/>
+        </p:nvSpPr>
+        <p:spPr>
+          <a:xfrm>
+            <a:off x="731520" y="2103120"/>
+            <a:ext cx="8138160" cy="502920"/>
+          </a:xfrm>
+          <a:prstGeom prst="roundRect">
+            <a:avLst>
+              <a:gd name="adj" fmla="val 21818"/>
+            </a:avLst>
+          </a:prstGeom>
+          <a:solidFill>
+            <a:srgbClr val="FFFFFF"/>
+          </a:solidFill>
+          <a:ln w="12700">
+            <a:solidFill>
+              <a:srgbClr val="2A10B4"/>
+            </a:solidFill>
+            <a:prstDash val="solid"/>
+          </a:ln>
+          <a:effectLst>
+            <a:outerShdw sx="100000" sy="100000" kx="0" ky="0" algn="bl" rotWithShape="0" blurRad="38100" dist="25400" dir="2700000">
+              <a:srgbClr val="000000">
+                <a:alpha val="25000"/>
+              </a:srgbClr>
+            </a:outerShdw>
+          </a:effectLst>
+        </p:spPr>
+      </p:sp>
+      <p:sp>
+        <p:nvSpPr>
+          <p:cNvPr id="8" name="pill-dot"/>
+          <p:cNvSpPr/>
+          <p:nvPr/>
+        </p:nvSpPr>
+        <p:spPr>
+          <a:xfrm>
+            <a:off x="822960" y="2176272"/>
+            <a:ext cx="356616" cy="356616"/>
+          </a:xfrm>
+          <a:prstGeom prst="ellipse">
+            <a:avLst/>
+          </a:prstGeom>
+          <a:solidFill>
+            <a:srgbClr val="2A10B4"/>
+          </a:solidFill>
+          <a:ln w="12700">
+            <a:solidFill>
+              <a:srgbClr val="2A10B4"/>
+            </a:solidFill>
+            <a:prstDash val="solid"/>
+          </a:ln>
+        </p:spPr>
+      </p:sp>
+      <p:sp>
+        <p:nvSpPr>
+          <p:cNvPr id="9" name="Text 7"/>
+          <p:cNvSpPr txBox="1"/>
+          <p:nvPr/>
+        </p:nvSpPr>
+        <p:spPr>
+          <a:xfrm>
+            <a:off x="822960" y="2176272"/>
+            <a:ext cx="356616" cy="356616"/>
+          </a:xfrm>
+          <a:prstGeom prst="rect">
+            <a:avLst/>
+          </a:prstGeom>
+          <a:noFill/>
+          <a:ln/>
+        </p:spPr>
+        <p:txBody>
+          <a:bodyPr wrap="square" lIns="0" tIns="0" rIns="0" bIns="0" rtlCol="0" anchor="ctr"/>
+          <a:lstStyle/>
           <a:p>
             <a:pPr algn="ctr" indent="0" marL="0">
               <a:buNone/>
             </a:pPr>
             <a:r>
-              <a:rPr lang="en-US" sz="1200" dirty="0">
-                <a:solidFill>
-                  <a:srgbClr val="333333"/>
+              <a:rPr lang="en-US" sz="1300" b="1" dirty="0">
+                <a:solidFill>
+                  <a:srgbClr val="FFFFFF"/>
                 </a:solidFill>
                 <a:latin typeface="Arial" pitchFamily="34" charset="0"/>
                 <a:ea typeface="Arial" pitchFamily="34" charset="-122"/>
                 <a:cs typeface="Arial" pitchFamily="34" charset="-120"/>
               </a:rPr>
-              <a:t>npm run seed:big</a:t>
-            </a:r>
-            <a:endParaRPr lang="en-US" sz="1200" dirty="0"/>
-          </a:p>
-        </p:txBody>
-      </p:sp>
-      <p:sp>
-        <p:nvSpPr>
-          <p:cNvPr id="7" name="stat-bg"/>
+              <a:t>2</a:t>
+            </a:r>
+            <a:endParaRPr lang="en-US" sz="1300" dirty="0"/>
+          </a:p>
+        </p:txBody>
+      </p:sp>
+      <p:sp>
+        <p:nvSpPr>
+          <p:cNvPr id="10" name="Text 8"/>
+          <p:cNvSpPr txBox="1"/>
+          <p:nvPr/>
+        </p:nvSpPr>
+        <p:spPr>
+          <a:xfrm>
+            <a:off x="1280160" y="2103120"/>
+            <a:ext cx="7498080" cy="502920"/>
+          </a:xfrm>
+          <a:prstGeom prst="rect">
+            <a:avLst/>
+          </a:prstGeom>
+          <a:noFill/>
+          <a:ln/>
+        </p:spPr>
+        <p:txBody>
+          <a:bodyPr wrap="square" lIns="0" tIns="0" rIns="0" bIns="0" rtlCol="0" anchor="ctr"/>
+          <a:lstStyle/>
+          <a:p>
+            <a:pPr indent="0" marL="0">
+              <a:buNone/>
+            </a:pPr>
+            <a:r>
+              <a:rPr lang="en-US" sz="1500" dirty="0">
+                <a:solidFill>
+                  <a:srgbClr val="1A1A1A"/>
+                </a:solidFill>
+                <a:latin typeface="Arial" pitchFamily="34" charset="0"/>
+                <a:ea typeface="Arial" pitchFamily="34" charset="-122"/>
+                <a:cs typeface="Arial" pitchFamily="34" charset="-120"/>
+              </a:rPr>
+              <a:t>Full-text: "nhan kim cuong 18k" · trigram: "nhan kim cuog solitare"</a:t>
+            </a:r>
+            <a:endParaRPr lang="en-US" sz="1500" dirty="0"/>
+          </a:p>
+        </p:txBody>
+      </p:sp>
+      <p:sp>
+        <p:nvSpPr>
+          <p:cNvPr id="11" name="pill"/>
           <p:cNvSpPr/>
           <p:nvPr/>
         </p:nvSpPr>
         <p:spPr>
           <a:xfrm>
-            <a:off x="6126480" y="2880360"/>
-            <a:ext cx="2743200" cy="1325880"/>
-          </a:xfrm>
-          <a:prstGeom prst="rect">
-            <a:avLst/>
+            <a:off x="731520" y="2743200"/>
+            <a:ext cx="8138160" cy="502920"/>
+          </a:xfrm>
+          <a:prstGeom prst="roundRect">
+            <a:avLst>
+              <a:gd name="adj" fmla="val 21818"/>
+            </a:avLst>
           </a:prstGeom>
           <a:solidFill>
-            <a:srgbClr val="EEF0FA"/>
+            <a:srgbClr val="FFFFFF"/>
           </a:solidFill>
           <a:ln w="12700">
             <a:solidFill>
-              <a:srgbClr val="EEF0FA"/>
+              <a:srgbClr val="2A10B4"/>
             </a:solidFill>
             <a:prstDash val="solid"/>
           </a:ln>
-        </p:spPr>
-      </p:sp>
-      <p:sp>
-        <p:nvSpPr>
-          <p:cNvPr id="8" name="stat-num"/>
+          <a:effectLst>
+            <a:outerShdw sx="100000" sy="100000" kx="0" ky="0" algn="bl" rotWithShape="0" blurRad="38100" dist="25400" dir="2700000">
+              <a:srgbClr val="000000">
+                <a:alpha val="25000"/>
+              </a:srgbClr>
+            </a:outerShdw>
+          </a:effectLst>
+        </p:spPr>
+      </p:sp>
+      <p:sp>
+        <p:nvSpPr>
+          <p:cNvPr id="12" name="pill-dot"/>
+          <p:cNvSpPr/>
+          <p:nvPr/>
+        </p:nvSpPr>
+        <p:spPr>
+          <a:xfrm>
+            <a:off x="822960" y="2816352"/>
+            <a:ext cx="356616" cy="356616"/>
+          </a:xfrm>
+          <a:prstGeom prst="ellipse">
+            <a:avLst/>
+          </a:prstGeom>
+          <a:solidFill>
+            <a:srgbClr val="2A10B4"/>
+          </a:solidFill>
+          <a:ln w="12700">
+            <a:solidFill>
+              <a:srgbClr val="2A10B4"/>
+            </a:solidFill>
+            <a:prstDash val="solid"/>
+          </a:ln>
+        </p:spPr>
+      </p:sp>
+      <p:sp>
+        <p:nvSpPr>
+          <p:cNvPr id="13" name="Text 11"/>
           <p:cNvSpPr txBox="1"/>
           <p:nvPr/>
         </p:nvSpPr>
         <p:spPr>
           <a:xfrm>
-            <a:off x="6126480" y="2953512"/>
-            <a:ext cx="2743200" cy="685800"/>
+            <a:off x="822960" y="2816352"/>
+            <a:ext cx="356616" cy="356616"/>
           </a:xfrm>
           <a:prstGeom prst="rect">
             <a:avLst/>
@@ -7021,30 +7283,30 @@
               <a:buNone/>
             </a:pPr>
             <a:r>
-              <a:rPr lang="en-US" sz="3200" b="1" dirty="0">
-                <a:solidFill>
-                  <a:srgbClr val="0B7285"/>
+              <a:rPr lang="en-US" sz="1300" b="1" dirty="0">
+                <a:solidFill>
+                  <a:srgbClr val="FFFFFF"/>
                 </a:solidFill>
                 <a:latin typeface="Arial" pitchFamily="34" charset="0"/>
                 <a:ea typeface="Arial" pitchFamily="34" charset="-122"/>
                 <a:cs typeface="Arial" pitchFamily="34" charset="-120"/>
               </a:rPr>
-              <a:t>1.090</a:t>
-            </a:r>
-            <a:endParaRPr lang="en-US" sz="3200" dirty="0"/>
-          </a:p>
-        </p:txBody>
-      </p:sp>
-      <p:sp>
-        <p:nvSpPr>
-          <p:cNvPr id="9" name="stat-label"/>
+              <a:t>3</a:t>
+            </a:r>
+            <a:endParaRPr lang="en-US" sz="1300" dirty="0"/>
+          </a:p>
+        </p:txBody>
+      </p:sp>
+      <p:sp>
+        <p:nvSpPr>
+          <p:cNvPr id="14" name="Text 12"/>
           <p:cNvSpPr txBox="1"/>
           <p:nvPr/>
         </p:nvSpPr>
         <p:spPr>
           <a:xfrm>
-            <a:off x="6217920" y="3657600"/>
-            <a:ext cx="2560320" cy="502920"/>
+            <a:off x="1280160" y="2743200"/>
+            <a:ext cx="7498080" cy="502920"/>
           </a:xfrm>
           <a:prstGeom prst="rect">
             <a:avLst/>
@@ -7053,54 +7315,135 @@
           <a:ln/>
         </p:spPr>
         <p:txBody>
-          <a:bodyPr wrap="square" lIns="0" tIns="0" rIns="0" bIns="0" rtlCol="0" anchor="t"/>
+          <a:bodyPr wrap="square" lIns="0" tIns="0" rIns="0" bIns="0" rtlCol="0" anchor="ctr"/>
           <a:lstStyle/>
           <a:p>
-            <a:pPr algn="ctr" indent="0" marL="0">
-              <a:buNone/>
-            </a:pPr>
-            <a:r>
-              <a:rPr lang="en-US" sz="1200" dirty="0">
-                <a:solidFill>
-                  <a:srgbClr val="333333"/>
+            <a:pPr indent="0" marL="0">
+              <a:buNone/>
+            </a:pPr>
+            <a:r>
+              <a:rPr lang="en-US" sz="1500" dirty="0">
+                <a:solidFill>
+                  <a:srgbClr val="1A1A1A"/>
                 </a:solidFill>
                 <a:latin typeface="Arial" pitchFamily="34" charset="0"/>
                 <a:ea typeface="Arial" pitchFamily="34" charset="-122"/>
                 <a:cs typeface="Arial" pitchFamily="34" charset="-120"/>
               </a:rPr>
-              <a:t>đơn hàng / giây</a:t>
-            </a:r>
-            <a:endParaRPr lang="en-US" sz="1200" dirty="0"/>
-          </a:p>
+              <a:t>pgvector: 8 sản phẩm giống nhẫn NK-001, ORDER BY embedding &lt;=&gt; …</a:t>
+            </a:r>
+            <a:endParaRPr lang="en-US" sz="1500" dirty="0"/>
+          </a:p>
+        </p:txBody>
+      </p:sp>
+      <p:sp>
+        <p:nvSpPr>
+          <p:cNvPr id="15" name="pill"/>
+          <p:cNvSpPr/>
+          <p:nvPr/>
+        </p:nvSpPr>
+        <p:spPr>
+          <a:xfrm>
+            <a:off x="731520" y="3383280"/>
+            <a:ext cx="8138160" cy="502920"/>
+          </a:xfrm>
+          <a:prstGeom prst="roundRect">
+            <a:avLst>
+              <a:gd name="adj" fmla="val 21818"/>
+            </a:avLst>
+          </a:prstGeom>
+          <a:solidFill>
+            <a:srgbClr val="FFFFFF"/>
+          </a:solidFill>
+          <a:ln w="12700">
+            <a:solidFill>
+              <a:srgbClr val="2A10B4"/>
+            </a:solidFill>
+            <a:prstDash val="solid"/>
+          </a:ln>
+          <a:effectLst>
+            <a:outerShdw sx="100000" sy="100000" kx="0" ky="0" algn="bl" rotWithShape="0" blurRad="38100" dist="25400" dir="2700000">
+              <a:srgbClr val="000000">
+                <a:alpha val="25000"/>
+              </a:srgbClr>
+            </a:outerShdw>
+          </a:effectLst>
+        </p:spPr>
+      </p:sp>
+      <p:sp>
+        <p:nvSpPr>
+          <p:cNvPr id="16" name="pill-dot"/>
+          <p:cNvSpPr/>
+          <p:nvPr/>
+        </p:nvSpPr>
+        <p:spPr>
+          <a:xfrm>
+            <a:off x="822960" y="3456432"/>
+            <a:ext cx="356616" cy="356616"/>
+          </a:xfrm>
+          <a:prstGeom prst="ellipse">
+            <a:avLst/>
+          </a:prstGeom>
+          <a:solidFill>
+            <a:srgbClr val="2A10B4"/>
+          </a:solidFill>
+          <a:ln w="12700">
+            <a:solidFill>
+              <a:srgbClr val="2A10B4"/>
+            </a:solidFill>
+            <a:prstDash val="solid"/>
+          </a:ln>
+        </p:spPr>
+      </p:sp>
+      <p:sp>
+        <p:nvSpPr>
+          <p:cNvPr id="17" name="Text 15"/>
+          <p:cNvSpPr txBox="1"/>
+          <p:nvPr/>
+        </p:nvSpPr>
+        <p:spPr>
+          <a:xfrm>
+            <a:off x="822960" y="3456432"/>
+            <a:ext cx="356616" cy="356616"/>
+          </a:xfrm>
+          <a:prstGeom prst="rect">
+            <a:avLst/>
+          </a:prstGeom>
+          <a:noFill/>
+          <a:ln/>
+        </p:spPr>
+        <p:txBody>
+          <a:bodyPr wrap="square" lIns="0" tIns="0" rIns="0" bIns="0" rtlCol="0" anchor="ctr"/>
+          <a:lstStyle/>
           <a:p>
             <a:pPr algn="ctr" indent="0" marL="0">
               <a:buNone/>
             </a:pPr>
             <a:r>
-              <a:rPr lang="en-US" sz="1200" dirty="0">
-                <a:solidFill>
-                  <a:srgbClr val="333333"/>
+              <a:rPr lang="en-US" sz="1300" b="1" dirty="0">
+                <a:solidFill>
+                  <a:srgbClr val="FFFFFF"/>
                 </a:solidFill>
                 <a:latin typeface="Arial" pitchFamily="34" charset="0"/>
                 <a:ea typeface="Arial" pitchFamily="34" charset="-122"/>
                 <a:cs typeface="Arial" pitchFamily="34" charset="-120"/>
               </a:rPr>
-              <a:t>30 client đồng thời</a:t>
-            </a:r>
-            <a:endParaRPr lang="en-US" sz="1200" dirty="0"/>
-          </a:p>
-        </p:txBody>
-      </p:sp>
-      <p:sp>
-        <p:nvSpPr>
-          <p:cNvPr id="10" name="bullets"/>
+              <a:t>4</a:t>
+            </a:r>
+            <a:endParaRPr lang="en-US" sz="1300" dirty="0"/>
+          </a:p>
+        </p:txBody>
+      </p:sp>
+      <p:sp>
+        <p:nvSpPr>
+          <p:cNvPr id="18" name="Text 16"/>
           <p:cNvSpPr txBox="1"/>
           <p:nvPr/>
         </p:nvSpPr>
         <p:spPr>
           <a:xfrm>
-            <a:off x="6126480" y="4389120"/>
-            <a:ext cx="2743200" cy="1920240"/>
+            <a:off x="1280160" y="3383280"/>
+            <a:ext cx="7498080" cy="502920"/>
           </a:xfrm>
           <a:prstGeom prst="rect">
             <a:avLst/>
@@ -7109,18 +7452,14 @@
           <a:ln/>
         </p:spPr>
         <p:txBody>
-          <a:bodyPr wrap="square" lIns="0" tIns="0" rIns="0" bIns="0" rtlCol="0" anchor="t"/>
+          <a:bodyPr wrap="square" lIns="0" tIns="0" rIns="0" bIns="0" rtlCol="0" anchor="ctr"/>
           <a:lstStyle/>
           <a:p>
-            <a:pPr marL="203200" indent="-203200">
-              <a:spcAft>
-                <a:spcPts val="600"/>
-              </a:spcAft>
-              <a:buSzPct val="100000"/>
-              <a:buChar char="•"/>
-            </a:pPr>
-            <a:r>
-              <a:rPr lang="en-US" sz="1300" dirty="0">
+            <a:pPr indent="0" marL="0">
+              <a:buNone/>
+            </a:pPr>
+            <a:r>
+              <a:rPr lang="en-US" sz="1500" dirty="0">
                 <a:solidFill>
                   <a:srgbClr val="1A1A1A"/>
                 </a:solidFill>
@@ -7128,30 +7467,361 @@
                 <a:ea typeface="Arial" pitchFamily="34" charset="-122"/>
                 <a:cs typeface="Arial" pitchFamily="34" charset="-120"/>
               </a:rPr>
-              <a:t>Tool đo npm run bench: 12 kịch bản × 5 lần, lấy trung vị, xuất Markdown/JSON</a:t>
-            </a:r>
-            <a:endParaRPr lang="en-US" sz="1300" dirty="0"/>
-          </a:p>
-          <a:p>
-            <a:pPr marL="203200" indent="-203200">
-              <a:spcAft>
-                <a:spcPts val="600"/>
-              </a:spcAft>
-              <a:buSzPct val="100000"/>
-              <a:buChar char="•"/>
-            </a:pPr>
-            <a:r>
-              <a:rPr lang="en-US" sz="1300" dirty="0">
-                <a:solidFill>
-                  <a:srgbClr val="1A1A1A"/>
+              <a:t>Partition: EXPLAIN chỉ quét 1/37 partition; BRIN 888 kB vs B-tree 23 MB</a:t>
+            </a:r>
+            <a:endParaRPr lang="en-US" sz="1500" dirty="0"/>
+          </a:p>
+        </p:txBody>
+      </p:sp>
+      <p:sp>
+        <p:nvSpPr>
+          <p:cNvPr id="19" name="pill"/>
+          <p:cNvSpPr/>
+          <p:nvPr/>
+        </p:nvSpPr>
+        <p:spPr>
+          <a:xfrm>
+            <a:off x="731520" y="4023360"/>
+            <a:ext cx="8138160" cy="502920"/>
+          </a:xfrm>
+          <a:prstGeom prst="roundRect">
+            <a:avLst>
+              <a:gd name="adj" fmla="val 21818"/>
+            </a:avLst>
+          </a:prstGeom>
+          <a:solidFill>
+            <a:srgbClr val="FFFFFF"/>
+          </a:solidFill>
+          <a:ln w="12700">
+            <a:solidFill>
+              <a:srgbClr val="2A10B4"/>
+            </a:solidFill>
+            <a:prstDash val="solid"/>
+          </a:ln>
+          <a:effectLst>
+            <a:outerShdw sx="100000" sy="100000" kx="0" ky="0" algn="bl" rotWithShape="0" blurRad="38100" dist="25400" dir="2700000">
+              <a:srgbClr val="000000">
+                <a:alpha val="25000"/>
+              </a:srgbClr>
+            </a:outerShdw>
+          </a:effectLst>
+        </p:spPr>
+      </p:sp>
+      <p:sp>
+        <p:nvSpPr>
+          <p:cNvPr id="20" name="pill-dot"/>
+          <p:cNvSpPr/>
+          <p:nvPr/>
+        </p:nvSpPr>
+        <p:spPr>
+          <a:xfrm>
+            <a:off x="822960" y="4096512"/>
+            <a:ext cx="356616" cy="356616"/>
+          </a:xfrm>
+          <a:prstGeom prst="ellipse">
+            <a:avLst/>
+          </a:prstGeom>
+          <a:solidFill>
+            <a:srgbClr val="2A10B4"/>
+          </a:solidFill>
+          <a:ln w="12700">
+            <a:solidFill>
+              <a:srgbClr val="2A10B4"/>
+            </a:solidFill>
+            <a:prstDash val="solid"/>
+          </a:ln>
+        </p:spPr>
+      </p:sp>
+      <p:sp>
+        <p:nvSpPr>
+          <p:cNvPr id="21" name="Text 19"/>
+          <p:cNvSpPr txBox="1"/>
+          <p:nvPr/>
+        </p:nvSpPr>
+        <p:spPr>
+          <a:xfrm>
+            <a:off x="822960" y="4096512"/>
+            <a:ext cx="356616" cy="356616"/>
+          </a:xfrm>
+          <a:prstGeom prst="rect">
+            <a:avLst/>
+          </a:prstGeom>
+          <a:noFill/>
+          <a:ln/>
+        </p:spPr>
+        <p:txBody>
+          <a:bodyPr wrap="square" lIns="0" tIns="0" rIns="0" bIns="0" rtlCol="0" anchor="ctr"/>
+          <a:lstStyle/>
+          <a:p>
+            <a:pPr algn="ctr" indent="0" marL="0">
+              <a:buNone/>
+            </a:pPr>
+            <a:r>
+              <a:rPr lang="en-US" sz="1300" b="1" dirty="0">
+                <a:solidFill>
+                  <a:srgbClr val="FFFFFF"/>
                 </a:solidFill>
                 <a:latin typeface="Arial" pitchFamily="34" charset="0"/>
                 <a:ea typeface="Arial" pitchFamily="34" charset="-122"/>
                 <a:cs typeface="Arial" pitchFamily="34" charset="-120"/>
               </a:rPr>
-              <a:t>Giám sát: pg_stat_statements, trang Monitor trong admin</a:t>
+              <a:t>5</a:t>
             </a:r>
             <a:endParaRPr lang="en-US" sz="1300" dirty="0"/>
+          </a:p>
+        </p:txBody>
+      </p:sp>
+      <p:sp>
+        <p:nvSpPr>
+          <p:cNvPr id="22" name="Text 20"/>
+          <p:cNvSpPr txBox="1"/>
+          <p:nvPr/>
+        </p:nvSpPr>
+        <p:spPr>
+          <a:xfrm>
+            <a:off x="1280160" y="4023360"/>
+            <a:ext cx="7498080" cy="502920"/>
+          </a:xfrm>
+          <a:prstGeom prst="rect">
+            <a:avLst/>
+          </a:prstGeom>
+          <a:noFill/>
+          <a:ln/>
+        </p:spPr>
+        <p:txBody>
+          <a:bodyPr wrap="square" lIns="0" tIns="0" rIns="0" bIns="0" rtlCol="0" anchor="ctr"/>
+          <a:lstStyle/>
+          <a:p>
+            <a:pPr indent="0" marL="0">
+              <a:buNone/>
+            </a:pPr>
+            <a:r>
+              <a:rPr lang="en-US" sz="1500" dirty="0">
+                <a:solidFill>
+                  <a:srgbClr val="1A1A1A"/>
+                </a:solidFill>
+                <a:latin typeface="Arial" pitchFamily="34" charset="0"/>
+                <a:ea typeface="Arial" pitchFamily="34" charset="-122"/>
+                <a:cs typeface="Arial" pitchFamily="34" charset="-120"/>
+              </a:rPr>
+              <a:t>place_order() 2 lần trên chiếc cuối → lần 2 báo OUT_OF_STOCK</a:t>
+            </a:r>
+            <a:endParaRPr lang="en-US" sz="1500" dirty="0"/>
+          </a:p>
+        </p:txBody>
+      </p:sp>
+      <p:sp>
+        <p:nvSpPr>
+          <p:cNvPr id="23" name="pill"/>
+          <p:cNvSpPr/>
+          <p:nvPr/>
+        </p:nvSpPr>
+        <p:spPr>
+          <a:xfrm>
+            <a:off x="731520" y="4663440"/>
+            <a:ext cx="8138160" cy="502920"/>
+          </a:xfrm>
+          <a:prstGeom prst="roundRect">
+            <a:avLst>
+              <a:gd name="adj" fmla="val 21818"/>
+            </a:avLst>
+          </a:prstGeom>
+          <a:solidFill>
+            <a:srgbClr val="FFFFFF"/>
+          </a:solidFill>
+          <a:ln w="12700">
+            <a:solidFill>
+              <a:srgbClr val="2A10B4"/>
+            </a:solidFill>
+            <a:prstDash val="solid"/>
+          </a:ln>
+          <a:effectLst>
+            <a:outerShdw sx="100000" sy="100000" kx="0" ky="0" algn="bl" rotWithShape="0" blurRad="38100" dist="25400" dir="2700000">
+              <a:srgbClr val="000000">
+                <a:alpha val="25000"/>
+              </a:srgbClr>
+            </a:outerShdw>
+          </a:effectLst>
+        </p:spPr>
+      </p:sp>
+      <p:sp>
+        <p:nvSpPr>
+          <p:cNvPr id="24" name="pill-dot"/>
+          <p:cNvSpPr/>
+          <p:nvPr/>
+        </p:nvSpPr>
+        <p:spPr>
+          <a:xfrm>
+            <a:off x="822960" y="4736592"/>
+            <a:ext cx="356616" cy="356616"/>
+          </a:xfrm>
+          <a:prstGeom prst="ellipse">
+            <a:avLst/>
+          </a:prstGeom>
+          <a:solidFill>
+            <a:srgbClr val="2A10B4"/>
+          </a:solidFill>
+          <a:ln w="12700">
+            <a:solidFill>
+              <a:srgbClr val="2A10B4"/>
+            </a:solidFill>
+            <a:prstDash val="solid"/>
+          </a:ln>
+        </p:spPr>
+      </p:sp>
+      <p:sp>
+        <p:nvSpPr>
+          <p:cNvPr id="25" name="Text 23"/>
+          <p:cNvSpPr txBox="1"/>
+          <p:nvPr/>
+        </p:nvSpPr>
+        <p:spPr>
+          <a:xfrm>
+            <a:off x="822960" y="4736592"/>
+            <a:ext cx="356616" cy="356616"/>
+          </a:xfrm>
+          <a:prstGeom prst="rect">
+            <a:avLst/>
+          </a:prstGeom>
+          <a:noFill/>
+          <a:ln/>
+        </p:spPr>
+        <p:txBody>
+          <a:bodyPr wrap="square" lIns="0" tIns="0" rIns="0" bIns="0" rtlCol="0" anchor="ctr"/>
+          <a:lstStyle/>
+          <a:p>
+            <a:pPr algn="ctr" indent="0" marL="0">
+              <a:buNone/>
+            </a:pPr>
+            <a:r>
+              <a:rPr lang="en-US" sz="1300" b="1" dirty="0">
+                <a:solidFill>
+                  <a:srgbClr val="FFFFFF"/>
+                </a:solidFill>
+                <a:latin typeface="Arial" pitchFamily="34" charset="0"/>
+                <a:ea typeface="Arial" pitchFamily="34" charset="-122"/>
+                <a:cs typeface="Arial" pitchFamily="34" charset="-120"/>
+              </a:rPr>
+              <a:t>6</a:t>
+            </a:r>
+            <a:endParaRPr lang="en-US" sz="1300" dirty="0"/>
+          </a:p>
+        </p:txBody>
+      </p:sp>
+      <p:sp>
+        <p:nvSpPr>
+          <p:cNvPr id="26" name="Text 24"/>
+          <p:cNvSpPr txBox="1"/>
+          <p:nvPr/>
+        </p:nvSpPr>
+        <p:spPr>
+          <a:xfrm>
+            <a:off x="1280160" y="4663440"/>
+            <a:ext cx="7498080" cy="502920"/>
+          </a:xfrm>
+          <a:prstGeom prst="rect">
+            <a:avLst/>
+          </a:prstGeom>
+          <a:noFill/>
+          <a:ln/>
+        </p:spPr>
+        <p:txBody>
+          <a:bodyPr wrap="square" lIns="0" tIns="0" rIns="0" bIns="0" rtlCol="0" anchor="ctr"/>
+          <a:lstStyle/>
+          <a:p>
+            <a:pPr indent="0" marL="0">
+              <a:buNone/>
+            </a:pPr>
+            <a:r>
+              <a:rPr lang="en-US" sz="1500" dirty="0">
+                <a:solidFill>
+                  <a:srgbClr val="1A1A1A"/>
+                </a:solidFill>
+                <a:latin typeface="Arial" pitchFamily="34" charset="0"/>
+                <a:ea typeface="Arial" pitchFamily="34" charset="-122"/>
+                <a:cs typeface="Arial" pitchFamily="34" charset="-120"/>
+              </a:rPr>
+              <a:t>mv_top_products 0,02 ms vs JOIN 1,5 triệu dòng 1,1 s; UPDATE stock → NOTIFY</a:t>
+            </a:r>
+            <a:endParaRPr lang="en-US" sz="1500" dirty="0"/>
+          </a:p>
+        </p:txBody>
+      </p:sp>
+      <p:sp>
+        <p:nvSpPr>
+          <p:cNvPr id="27" name="Text 25"/>
+          <p:cNvSpPr txBox="1"/>
+          <p:nvPr/>
+        </p:nvSpPr>
+        <p:spPr>
+          <a:xfrm>
+            <a:off x="731520" y="5486400"/>
+            <a:ext cx="8138160" cy="411480"/>
+          </a:xfrm>
+          <a:prstGeom prst="rect">
+            <a:avLst/>
+          </a:prstGeom>
+          <a:noFill/>
+          <a:ln/>
+        </p:spPr>
+        <p:txBody>
+          <a:bodyPr wrap="square" lIns="0" tIns="0" rIns="0" bIns="0" rtlCol="0" anchor="t"/>
+          <a:lstStyle/>
+          <a:p>
+            <a:pPr indent="0" marL="0">
+              <a:buNone/>
+            </a:pPr>
+            <a:r>
+              <a:rPr lang="en-US" sz="1400" i="1" dirty="0">
+                <a:solidFill>
+                  <a:srgbClr val="444444"/>
+                </a:solidFill>
+                <a:latin typeface="Arial" pitchFamily="34" charset="0"/>
+                <a:ea typeface="Arial" pitchFamily="34" charset="-122"/>
+                <a:cs typeface="Arial" pitchFamily="34" charset="-120"/>
+              </a:rPr>
+              <a:t>Kết nối: localhost:5432 · db jewelry · postgres / postgres  —  mở file, chọn khối lệnh, Cmd+Enter</a:t>
+            </a:r>
+            <a:endParaRPr lang="en-US" sz="1400" dirty="0"/>
+          </a:p>
+        </p:txBody>
+      </p:sp>
+      <p:sp>
+        <p:nvSpPr>
+          <p:cNvPr id="28" name="Text 26"/>
+          <p:cNvSpPr txBox="1"/>
+          <p:nvPr/>
+        </p:nvSpPr>
+        <p:spPr>
+          <a:xfrm>
+            <a:off x="731520" y="5897880"/>
+            <a:ext cx="8138160" cy="411480"/>
+          </a:xfrm>
+          <a:prstGeom prst="rect">
+            <a:avLst/>
+          </a:prstGeom>
+          <a:noFill/>
+          <a:ln/>
+        </p:spPr>
+        <p:txBody>
+          <a:bodyPr wrap="square" lIns="0" tIns="0" rIns="0" bIns="0" rtlCol="0" anchor="t"/>
+          <a:lstStyle/>
+          <a:p>
+            <a:pPr indent="0" marL="0">
+              <a:buNone/>
+            </a:pPr>
+            <a:r>
+              <a:rPr lang="en-US" sz="1400" i="1" dirty="0">
+                <a:solidFill>
+                  <a:srgbClr val="444444"/>
+                </a:solidFill>
+                <a:latin typeface="Arial" pitchFamily="34" charset="0"/>
+                <a:ea typeface="Arial" pitchFamily="34" charset="-122"/>
+                <a:cs typeface="Arial" pitchFamily="34" charset="-120"/>
+              </a:rPr>
+              <a:t>Web: localhost:3000  ·  Admin → Monitor &amp; Benchmark: EXPLAIN có/không index ngay trên giao diện</a:t>
+            </a:r>
+            <a:endParaRPr lang="en-US" sz="1400" dirty="0"/>
           </a:p>
         </p:txBody>
       </p:sp>
@@ -7263,22 +7933,278 @@
                 <a:ea typeface="Trebuchet MS" pitchFamily="34" charset="-122"/>
                 <a:cs typeface="Trebuchet MS" pitchFamily="34" charset="-120"/>
               </a:rPr>
-              <a:t>Kết luận</a:t>
+              <a:t>Benchmark: có index nhanh hơn bao nhiêu?</a:t>
             </a:r>
             <a:endParaRPr lang="en-US" sz="2800" dirty="0"/>
           </a:p>
         </p:txBody>
       </p:sp>
-      <p:sp>
-        <p:nvSpPr>
-          <p:cNvPr id="3" name="bullets"/>
+      <p:graphicFrame>
+        <p:nvGraphicFramePr>
+          <p:cNvPr id="3" name="speedup-chart" descr=""/>
+          <p:cNvGraphicFramePr/>
+          <p:nvPr/>
+        </p:nvGraphicFramePr>
+        <p:xfrm>
+          <a:off x="731520" y="1371600"/>
+          <a:ext cx="5212080" cy="4937760"/>
+        </p:xfrm>
+        <a:graphic xmlns:a="http://schemas.openxmlformats.org/drawingml/2006/main">
+          <a:graphicData uri="http://schemas.openxmlformats.org/drawingml/2006/chart">
+            <c:chart xmlns:c="http://schemas.openxmlformats.org/drawingml/2006/chart" r:id="rId1"/>
+          </a:graphicData>
+        </a:graphic>
+      </p:graphicFrame>
+      <p:sp>
+        <p:nvSpPr>
+          <p:cNvPr id="4" name="stat-bg"/>
+          <p:cNvSpPr/>
+          <p:nvPr/>
+        </p:nvSpPr>
+        <p:spPr>
+          <a:xfrm>
+            <a:off x="6126480" y="1417320"/>
+            <a:ext cx="2743200" cy="1325880"/>
+          </a:xfrm>
+          <a:prstGeom prst="rect">
+            <a:avLst/>
+          </a:prstGeom>
+          <a:solidFill>
+            <a:srgbClr val="EEF0FA"/>
+          </a:solidFill>
+          <a:ln w="12700">
+            <a:solidFill>
+              <a:srgbClr val="EEF0FA"/>
+            </a:solidFill>
+            <a:prstDash val="solid"/>
+          </a:ln>
+        </p:spPr>
+      </p:sp>
+      <p:sp>
+        <p:nvSpPr>
+          <p:cNvPr id="5" name="stat-num"/>
           <p:cNvSpPr txBox="1"/>
           <p:nvPr/>
         </p:nvSpPr>
         <p:spPr>
           <a:xfrm>
-            <a:off x="731520" y="1508760"/>
-            <a:ext cx="8138160" cy="3840480"/>
+            <a:off x="6126480" y="1490472"/>
+            <a:ext cx="2743200" cy="685800"/>
+          </a:xfrm>
+          <a:prstGeom prst="rect">
+            <a:avLst/>
+          </a:prstGeom>
+          <a:noFill/>
+          <a:ln/>
+        </p:spPr>
+        <p:txBody>
+          <a:bodyPr wrap="square" lIns="0" tIns="0" rIns="0" bIns="0" rtlCol="0" anchor="ctr"/>
+          <a:lstStyle/>
+          <a:p>
+            <a:pPr algn="ctr" indent="0" marL="0">
+              <a:buNone/>
+            </a:pPr>
+            <a:r>
+              <a:rPr lang="en-US" sz="3200" b="1" dirty="0">
+                <a:solidFill>
+                  <a:srgbClr val="1E8E3E"/>
+                </a:solidFill>
+                <a:latin typeface="Arial" pitchFamily="34" charset="0"/>
+                <a:ea typeface="Arial" pitchFamily="34" charset="-122"/>
+                <a:cs typeface="Arial" pitchFamily="34" charset="-120"/>
+              </a:rPr>
+              <a:t>1 triệu</a:t>
+            </a:r>
+            <a:endParaRPr lang="en-US" sz="3200" dirty="0"/>
+          </a:p>
+        </p:txBody>
+      </p:sp>
+      <p:sp>
+        <p:nvSpPr>
+          <p:cNvPr id="6" name="stat-label"/>
+          <p:cNvSpPr txBox="1"/>
+          <p:nvPr/>
+        </p:nvSpPr>
+        <p:spPr>
+          <a:xfrm>
+            <a:off x="6217920" y="2194560"/>
+            <a:ext cx="2560320" cy="502920"/>
+          </a:xfrm>
+          <a:prstGeom prst="rect">
+            <a:avLst/>
+          </a:prstGeom>
+          <a:noFill/>
+          <a:ln/>
+        </p:spPr>
+        <p:txBody>
+          <a:bodyPr wrap="square" lIns="0" tIns="0" rIns="0" bIns="0" rtlCol="0" anchor="t"/>
+          <a:lstStyle/>
+          <a:p>
+            <a:pPr algn="ctr" indent="0" marL="0">
+              <a:buNone/>
+            </a:pPr>
+            <a:r>
+              <a:rPr lang="en-US" sz="1200" dirty="0">
+                <a:solidFill>
+                  <a:srgbClr val="333333"/>
+                </a:solidFill>
+                <a:latin typeface="Arial" pitchFamily="34" charset="0"/>
+                <a:ea typeface="Arial" pitchFamily="34" charset="-122"/>
+                <a:cs typeface="Arial" pitchFamily="34" charset="-120"/>
+              </a:rPr>
+              <a:t>đơn hàng / 37 partition</a:t>
+            </a:r>
+            <a:endParaRPr lang="en-US" sz="1200" dirty="0"/>
+          </a:p>
+          <a:p>
+            <a:pPr algn="ctr" indent="0" marL="0">
+              <a:buNone/>
+            </a:pPr>
+            <a:r>
+              <a:rPr lang="en-US" sz="1200" dirty="0">
+                <a:solidFill>
+                  <a:srgbClr val="333333"/>
+                </a:solidFill>
+                <a:latin typeface="Arial" pitchFamily="34" charset="0"/>
+                <a:ea typeface="Arial" pitchFamily="34" charset="-122"/>
+                <a:cs typeface="Arial" pitchFamily="34" charset="-120"/>
+              </a:rPr>
+              <a:t>npm run seed:big</a:t>
+            </a:r>
+            <a:endParaRPr lang="en-US" sz="1200" dirty="0"/>
+          </a:p>
+        </p:txBody>
+      </p:sp>
+      <p:sp>
+        <p:nvSpPr>
+          <p:cNvPr id="7" name="stat-bg"/>
+          <p:cNvSpPr/>
+          <p:nvPr/>
+        </p:nvSpPr>
+        <p:spPr>
+          <a:xfrm>
+            <a:off x="6126480" y="2880360"/>
+            <a:ext cx="2743200" cy="1325880"/>
+          </a:xfrm>
+          <a:prstGeom prst="rect">
+            <a:avLst/>
+          </a:prstGeom>
+          <a:solidFill>
+            <a:srgbClr val="EEF0FA"/>
+          </a:solidFill>
+          <a:ln w="12700">
+            <a:solidFill>
+              <a:srgbClr val="EEF0FA"/>
+            </a:solidFill>
+            <a:prstDash val="solid"/>
+          </a:ln>
+        </p:spPr>
+      </p:sp>
+      <p:sp>
+        <p:nvSpPr>
+          <p:cNvPr id="8" name="stat-num"/>
+          <p:cNvSpPr txBox="1"/>
+          <p:nvPr/>
+        </p:nvSpPr>
+        <p:spPr>
+          <a:xfrm>
+            <a:off x="6126480" y="2953512"/>
+            <a:ext cx="2743200" cy="685800"/>
+          </a:xfrm>
+          <a:prstGeom prst="rect">
+            <a:avLst/>
+          </a:prstGeom>
+          <a:noFill/>
+          <a:ln/>
+        </p:spPr>
+        <p:txBody>
+          <a:bodyPr wrap="square" lIns="0" tIns="0" rIns="0" bIns="0" rtlCol="0" anchor="ctr"/>
+          <a:lstStyle/>
+          <a:p>
+            <a:pPr algn="ctr" indent="0" marL="0">
+              <a:buNone/>
+            </a:pPr>
+            <a:r>
+              <a:rPr lang="en-US" sz="3200" b="1" dirty="0">
+                <a:solidFill>
+                  <a:srgbClr val="0B7285"/>
+                </a:solidFill>
+                <a:latin typeface="Arial" pitchFamily="34" charset="0"/>
+                <a:ea typeface="Arial" pitchFamily="34" charset="-122"/>
+                <a:cs typeface="Arial" pitchFamily="34" charset="-120"/>
+              </a:rPr>
+              <a:t>1.090</a:t>
+            </a:r>
+            <a:endParaRPr lang="en-US" sz="3200" dirty="0"/>
+          </a:p>
+        </p:txBody>
+      </p:sp>
+      <p:sp>
+        <p:nvSpPr>
+          <p:cNvPr id="9" name="stat-label"/>
+          <p:cNvSpPr txBox="1"/>
+          <p:nvPr/>
+        </p:nvSpPr>
+        <p:spPr>
+          <a:xfrm>
+            <a:off x="6217920" y="3657600"/>
+            <a:ext cx="2560320" cy="502920"/>
+          </a:xfrm>
+          <a:prstGeom prst="rect">
+            <a:avLst/>
+          </a:prstGeom>
+          <a:noFill/>
+          <a:ln/>
+        </p:spPr>
+        <p:txBody>
+          <a:bodyPr wrap="square" lIns="0" tIns="0" rIns="0" bIns="0" rtlCol="0" anchor="t"/>
+          <a:lstStyle/>
+          <a:p>
+            <a:pPr algn="ctr" indent="0" marL="0">
+              <a:buNone/>
+            </a:pPr>
+            <a:r>
+              <a:rPr lang="en-US" sz="1200" dirty="0">
+                <a:solidFill>
+                  <a:srgbClr val="333333"/>
+                </a:solidFill>
+                <a:latin typeface="Arial" pitchFamily="34" charset="0"/>
+                <a:ea typeface="Arial" pitchFamily="34" charset="-122"/>
+                <a:cs typeface="Arial" pitchFamily="34" charset="-120"/>
+              </a:rPr>
+              <a:t>đơn hàng / giây</a:t>
+            </a:r>
+            <a:endParaRPr lang="en-US" sz="1200" dirty="0"/>
+          </a:p>
+          <a:p>
+            <a:pPr algn="ctr" indent="0" marL="0">
+              <a:buNone/>
+            </a:pPr>
+            <a:r>
+              <a:rPr lang="en-US" sz="1200" dirty="0">
+                <a:solidFill>
+                  <a:srgbClr val="333333"/>
+                </a:solidFill>
+                <a:latin typeface="Arial" pitchFamily="34" charset="0"/>
+                <a:ea typeface="Arial" pitchFamily="34" charset="-122"/>
+                <a:cs typeface="Arial" pitchFamily="34" charset="-120"/>
+              </a:rPr>
+              <a:t>30 client đồng thời</a:t>
+            </a:r>
+            <a:endParaRPr lang="en-US" sz="1200" dirty="0"/>
+          </a:p>
+        </p:txBody>
+      </p:sp>
+      <p:sp>
+        <p:nvSpPr>
+          <p:cNvPr id="10" name="bullets"/>
+          <p:cNvSpPr txBox="1"/>
+          <p:nvPr/>
+        </p:nvSpPr>
+        <p:spPr>
+          <a:xfrm>
+            <a:off x="6126480" y="4389120"/>
+            <a:ext cx="2743200" cy="1920240"/>
           </a:xfrm>
           <a:prstGeom prst="rect">
             <a:avLst/>
@@ -7298,7 +8224,7 @@
               <a:buChar char="•"/>
             </a:pPr>
             <a:r>
-              <a:rPr lang="en-US" sz="1800" dirty="0">
+              <a:rPr lang="en-US" sz="1300" dirty="0">
                 <a:solidFill>
                   <a:srgbClr val="1A1A1A"/>
                 </a:solidFill>
@@ -7306,9 +8232,9 @@
                 <a:ea typeface="Arial" pitchFamily="34" charset="-122"/>
                 <a:cs typeface="Arial" pitchFamily="34" charset="-120"/>
               </a:rPr>
-              <a:t>PostgreSQL = CSDL quan hệ + đa mô hình: một hệ thống thay cho search engine, cache, hàng đợi và vector DB</a:t>
-            </a:r>
-            <a:endParaRPr lang="en-US" sz="1800" dirty="0"/>
+              <a:t>Tool đo npm run bench: 12 kịch bản × 5 lần, lấy trung vị, xuất Markdown/JSON</a:t>
+            </a:r>
+            <a:endParaRPr lang="en-US" sz="1300" dirty="0"/>
           </a:p>
           <a:p>
             <a:pPr marL="203200" indent="-203200">
@@ -7319,7 +8245,7 @@
               <a:buChar char="•"/>
             </a:pPr>
             <a:r>
-              <a:rPr lang="en-US" sz="1800" dirty="0">
+              <a:rPr lang="en-US" sz="1300" dirty="0">
                 <a:solidFill>
                   <a:srgbClr val="1A1A1A"/>
                 </a:solidFill>
@@ -7327,90 +8253,9 @@
                 <a:ea typeface="Arial" pitchFamily="34" charset="-122"/>
                 <a:cs typeface="Arial" pitchFamily="34" charset="-120"/>
               </a:rPr>
-              <a:t>6 tính năng gắn 6 nghiệp vụ, đo trên 1 triệu đơn: nhanh hơn 2,6× – 1.000×; 50 client đồng thời không bán quá kho</a:t>
-            </a:r>
-            <a:endParaRPr lang="en-US" sz="1800" dirty="0"/>
-          </a:p>
-          <a:p>
-            <a:pPr marL="203200" indent="-203200">
-              <a:spcAft>
-                <a:spcPts val="600"/>
-              </a:spcAft>
-              <a:buSzPct val="100000"/>
-              <a:buChar char="•"/>
-            </a:pPr>
-            <a:r>
-              <a:rPr lang="en-US" sz="1800" dirty="0">
-                <a:solidFill>
-                  <a:srgbClr val="1A1A1A"/>
-                </a:solidFill>
-                <a:latin typeface="Arial" pitchFamily="34" charset="0"/>
-                <a:ea typeface="Arial" pitchFamily="34" charset="-122"/>
-                <a:cs typeface="Arial" pitchFamily="34" charset="-120"/>
-              </a:rPr>
-              <a:t>Hạn chế: embedding feature hashing, chưa có từ điển tiếng Việt, chưa tinh chỉnh tham số PostgreSQL</a:t>
-            </a:r>
-            <a:endParaRPr lang="en-US" sz="1800" dirty="0"/>
-          </a:p>
-          <a:p>
-            <a:pPr marL="203200" indent="-203200">
-              <a:spcAft>
-                <a:spcPts val="600"/>
-              </a:spcAft>
-              <a:buSzPct val="100000"/>
-              <a:buChar char="•"/>
-            </a:pPr>
-            <a:r>
-              <a:rPr lang="en-US" sz="1800" dirty="0">
-                <a:solidFill>
-                  <a:srgbClr val="1A1A1A"/>
-                </a:solidFill>
-                <a:latin typeface="Arial" pitchFamily="34" charset="0"/>
-                <a:ea typeface="Arial" pitchFamily="34" charset="-122"/>
-                <a:cs typeface="Arial" pitchFamily="34" charset="-120"/>
-              </a:rPr>
-              <a:t>Hướng phát triển: embedding CLIP theo ảnh, pg_cron tự tạo partition &amp; refresh, replication</a:t>
-            </a:r>
-            <a:endParaRPr lang="en-US" sz="1800" dirty="0"/>
-          </a:p>
-        </p:txBody>
-      </p:sp>
-      <p:sp>
-        <p:nvSpPr>
-          <p:cNvPr id="4" name="Text 2"/>
-          <p:cNvSpPr txBox="1"/>
-          <p:nvPr/>
-        </p:nvSpPr>
-        <p:spPr>
-          <a:xfrm>
-            <a:off x="731520" y="5486400"/>
-            <a:ext cx="8138160" cy="731520"/>
-          </a:xfrm>
-          <a:prstGeom prst="rect">
-            <a:avLst/>
-          </a:prstGeom>
-          <a:noFill/>
-          <a:ln/>
-        </p:spPr>
-        <p:txBody>
-          <a:bodyPr wrap="square" lIns="0" tIns="0" rIns="0" bIns="0" rtlCol="0" anchor="ctr"/>
-          <a:lstStyle/>
-          <a:p>
-            <a:pPr algn="ctr" indent="0" marL="0">
-              <a:buNone/>
-            </a:pPr>
-            <a:r>
-              <a:rPr lang="en-US" sz="2800" b="1" dirty="0">
-                <a:solidFill>
-                  <a:srgbClr val="2A10B4"/>
-                </a:solidFill>
-                <a:latin typeface="Trebuchet MS" pitchFamily="34" charset="0"/>
-                <a:ea typeface="Trebuchet MS" pitchFamily="34" charset="-122"/>
-                <a:cs typeface="Trebuchet MS" pitchFamily="34" charset="-120"/>
-              </a:rPr>
-              <a:t>Cảm ơn cô và các bạn đã lắng nghe!</a:t>
-            </a:r>
-            <a:endParaRPr lang="en-US" sz="2800" dirty="0"/>
+              <a:t>Giám sát: pg_stat_statements, trang Monitor trong admin</a:t>
+            </a:r>
+            <a:endParaRPr lang="en-US" sz="1300" dirty="0"/>
           </a:p>
         </p:txBody>
       </p:sp>
@@ -7457,6 +8302,265 @@
             <a:fld id="{F7021451-1387-4CA6-816F-3879F97B5CBC}" type="slidenum">
               <a:rPr b="0" lang="en-US"/>
               <a:t>16</a:t>
+            </a:fld>
+            <a:endParaRPr lang="en-US"/>
+          </a:p>
+        </p:txBody>
+      </p:sp>
+    </p:spTree>
+  </p:cSld>
+  <p:clrMapOvr>
+    <a:masterClrMapping/>
+  </p:clrMapOvr>
+</p:sld>
+</file>
+
+<file path=ppt/slides/slide17.xml><?xml version="1.0" encoding="utf-8"?>
+<p:sld xmlns:a="http://schemas.openxmlformats.org/drawingml/2006/main" xmlns:r="http://schemas.openxmlformats.org/officeDocument/2006/relationships" xmlns:p="http://schemas.openxmlformats.org/presentationml/2006/main">
+  <p:cSld name="Slide 17">
+    <p:spTree>
+      <p:nvGrpSpPr>
+        <p:cNvPr id="1" name=""/>
+        <p:cNvGrpSpPr/>
+        <p:nvPr/>
+      </p:nvGrpSpPr>
+      <p:grpSpPr>
+        <a:xfrm>
+          <a:off x="0" y="0"/>
+          <a:ext cx="0" cy="0"/>
+          <a:chOff x="0" y="0"/>
+          <a:chExt cx="0" cy="0"/>
+        </a:xfrm>
+      </p:grpSpPr>
+      <p:sp>
+        <p:nvSpPr>
+          <p:cNvPr id="2" name="Text 3"/>
+          <p:cNvSpPr/>
+          <p:nvPr>
+            <p:ph idx="104" type="title" hasCustomPrompt="1"/>
+          </p:nvPr>
+        </p:nvSpPr>
+        <p:spPr>
+          <a:xfrm>
+            <a:off x="640080" y="457200"/>
+            <a:ext cx="8412480" cy="749808"/>
+          </a:xfrm>
+          <a:prstGeom prst="rect">
+            <a:avLst/>
+          </a:prstGeom>
+          <a:noFill/>
+          <a:ln/>
+        </p:spPr>
+        <p:txBody>
+          <a:bodyPr wrap="square" lIns="0" tIns="0" rIns="0" bIns="0" rtlCol="0" anchor="ctr"/>
+          <a:lstStyle/>
+          <a:p>
+            <a:pPr algn="l" indent="0" marL="0">
+              <a:buNone/>
+            </a:pPr>
+            <a:r>
+              <a:rPr lang="en-US" sz="2800" b="1" dirty="0">
+                <a:solidFill>
+                  <a:srgbClr val="FFFFFF"/>
+                </a:solidFill>
+                <a:latin typeface="Trebuchet MS" pitchFamily="34" charset="0"/>
+                <a:ea typeface="Trebuchet MS" pitchFamily="34" charset="-122"/>
+                <a:cs typeface="Trebuchet MS" pitchFamily="34" charset="-120"/>
+              </a:rPr>
+              <a:t>Kết luận</a:t>
+            </a:r>
+            <a:endParaRPr lang="en-US" sz="2800" dirty="0"/>
+          </a:p>
+        </p:txBody>
+      </p:sp>
+      <p:sp>
+        <p:nvSpPr>
+          <p:cNvPr id="3" name="bullets"/>
+          <p:cNvSpPr txBox="1"/>
+          <p:nvPr/>
+        </p:nvSpPr>
+        <p:spPr>
+          <a:xfrm>
+            <a:off x="731520" y="1508760"/>
+            <a:ext cx="8138160" cy="3840480"/>
+          </a:xfrm>
+          <a:prstGeom prst="rect">
+            <a:avLst/>
+          </a:prstGeom>
+          <a:noFill/>
+          <a:ln/>
+        </p:spPr>
+        <p:txBody>
+          <a:bodyPr wrap="square" lIns="0" tIns="0" rIns="0" bIns="0" rtlCol="0" anchor="t"/>
+          <a:lstStyle/>
+          <a:p>
+            <a:pPr marL="203200" indent="-203200">
+              <a:spcAft>
+                <a:spcPts val="600"/>
+              </a:spcAft>
+              <a:buSzPct val="100000"/>
+              <a:buChar char="•"/>
+            </a:pPr>
+            <a:r>
+              <a:rPr lang="en-US" sz="1800" dirty="0">
+                <a:solidFill>
+                  <a:srgbClr val="1A1A1A"/>
+                </a:solidFill>
+                <a:latin typeface="Arial" pitchFamily="34" charset="0"/>
+                <a:ea typeface="Arial" pitchFamily="34" charset="-122"/>
+                <a:cs typeface="Arial" pitchFamily="34" charset="-120"/>
+              </a:rPr>
+              <a:t>PostgreSQL = CSDL quan hệ + đa mô hình: một hệ thống thay cho search engine, cache, hàng đợi và vector DB</a:t>
+            </a:r>
+            <a:endParaRPr lang="en-US" sz="1800" dirty="0"/>
+          </a:p>
+          <a:p>
+            <a:pPr marL="203200" indent="-203200">
+              <a:spcAft>
+                <a:spcPts val="600"/>
+              </a:spcAft>
+              <a:buSzPct val="100000"/>
+              <a:buChar char="•"/>
+            </a:pPr>
+            <a:r>
+              <a:rPr lang="en-US" sz="1800" dirty="0">
+                <a:solidFill>
+                  <a:srgbClr val="1A1A1A"/>
+                </a:solidFill>
+                <a:latin typeface="Arial" pitchFamily="34" charset="0"/>
+                <a:ea typeface="Arial" pitchFamily="34" charset="-122"/>
+                <a:cs typeface="Arial" pitchFamily="34" charset="-120"/>
+              </a:rPr>
+              <a:t>6 tính năng gắn 6 nghiệp vụ, đo trên 1 triệu đơn: nhanh hơn 2,6× – 1.000×; 50 client đồng thời không bán quá kho</a:t>
+            </a:r>
+            <a:endParaRPr lang="en-US" sz="1800" dirty="0"/>
+          </a:p>
+          <a:p>
+            <a:pPr marL="203200" indent="-203200">
+              <a:spcAft>
+                <a:spcPts val="600"/>
+              </a:spcAft>
+              <a:buSzPct val="100000"/>
+              <a:buChar char="•"/>
+            </a:pPr>
+            <a:r>
+              <a:rPr lang="en-US" sz="1800" dirty="0">
+                <a:solidFill>
+                  <a:srgbClr val="1A1A1A"/>
+                </a:solidFill>
+                <a:latin typeface="Arial" pitchFamily="34" charset="0"/>
+                <a:ea typeface="Arial" pitchFamily="34" charset="-122"/>
+                <a:cs typeface="Arial" pitchFamily="34" charset="-120"/>
+              </a:rPr>
+              <a:t>Hạn chế: embedding feature hashing, chưa có từ điển tiếng Việt, chưa tinh chỉnh tham số PostgreSQL</a:t>
+            </a:r>
+            <a:endParaRPr lang="en-US" sz="1800" dirty="0"/>
+          </a:p>
+          <a:p>
+            <a:pPr marL="203200" indent="-203200">
+              <a:spcAft>
+                <a:spcPts val="600"/>
+              </a:spcAft>
+              <a:buSzPct val="100000"/>
+              <a:buChar char="•"/>
+            </a:pPr>
+            <a:r>
+              <a:rPr lang="en-US" sz="1800" dirty="0">
+                <a:solidFill>
+                  <a:srgbClr val="1A1A1A"/>
+                </a:solidFill>
+                <a:latin typeface="Arial" pitchFamily="34" charset="0"/>
+                <a:ea typeface="Arial" pitchFamily="34" charset="-122"/>
+                <a:cs typeface="Arial" pitchFamily="34" charset="-120"/>
+              </a:rPr>
+              <a:t>Hướng phát triển: embedding CLIP theo ảnh, pg_cron tự tạo partition &amp; refresh, replication</a:t>
+            </a:r>
+            <a:endParaRPr lang="en-US" sz="1800" dirty="0"/>
+          </a:p>
+        </p:txBody>
+      </p:sp>
+      <p:sp>
+        <p:nvSpPr>
+          <p:cNvPr id="4" name="Text 2"/>
+          <p:cNvSpPr txBox="1"/>
+          <p:nvPr/>
+        </p:nvSpPr>
+        <p:spPr>
+          <a:xfrm>
+            <a:off x="731520" y="5486400"/>
+            <a:ext cx="8138160" cy="731520"/>
+          </a:xfrm>
+          <a:prstGeom prst="rect">
+            <a:avLst/>
+          </a:prstGeom>
+          <a:noFill/>
+          <a:ln/>
+        </p:spPr>
+        <p:txBody>
+          <a:bodyPr wrap="square" lIns="0" tIns="0" rIns="0" bIns="0" rtlCol="0" anchor="ctr"/>
+          <a:lstStyle/>
+          <a:p>
+            <a:pPr algn="ctr" indent="0" marL="0">
+              <a:buNone/>
+            </a:pPr>
+            <a:r>
+              <a:rPr lang="en-US" sz="2800" b="1" dirty="0">
+                <a:solidFill>
+                  <a:srgbClr val="2A10B4"/>
+                </a:solidFill>
+                <a:latin typeface="Trebuchet MS" pitchFamily="34" charset="0"/>
+                <a:ea typeface="Trebuchet MS" pitchFamily="34" charset="-122"/>
+                <a:cs typeface="Trebuchet MS" pitchFamily="34" charset="-120"/>
+              </a:rPr>
+              <a:t>Cảm ơn cô và các bạn đã lắng nghe!</a:t>
+            </a:r>
+            <a:endParaRPr lang="en-US" sz="2800" dirty="0"/>
+          </a:p>
+        </p:txBody>
+      </p:sp>
+      <p:sp>
+        <p:nvSpPr>
+          <p:cNvPr id="25" name="Slide Number Placeholder 0"/>
+          <p:cNvSpPr>
+            <a:spLocks noGrp="1"/>
+          </p:cNvSpPr>
+          <p:nvPr>
+            <p:ph type="sldNum" sz="quarter" idx="4294967295"/>
+          </p:nvPr>
+        </p:nvSpPr>
+        <p:spPr>
+          <a:xfrm>
+            <a:off x="8503920" y="6492240"/>
+            <a:ext cx="457200" cy="274320"/>
+          </a:xfrm>
+          <a:prstGeom prst="rect">
+            <a:avLst/>
+          </a:prstGeom>
+          <a:extLst>
+            <a:ext uri="{C572A759-6A51-4108-AA02-DFA0A04FC94B}">
+              <ma14:wrappingTextBoxFlag xmlns:ma14="http://schemas.microsoft.com/office/mac/drawingml/2011/main" val="0"/>
+            </a:ext>
+          </a:extLst>
+        </p:spPr>
+        <p:txBody>
+          <a:bodyPr/>
+          <a:lstStyle>
+            <a:lvl1pPr>
+              <a:defRPr sz="1100">
+                <a:solidFill>
+                  <a:srgbClr val="1A1A1A"/>
+                </a:solidFill>
+                <a:latin typeface="Arial"/>
+                <a:ea typeface="Arial"/>
+                <a:cs typeface="Arial"/>
+              </a:defRPr>
+            </a:lvl1pPr>
+          </a:lstStyle>
+          <a:p>
+            <a:pPr algn="r"/>
+            <a:fld id="{F7021451-1387-4CA6-816F-3879F97B5CBC}" type="slidenum">
+              <a:rPr b="0" lang="en-US"/>
+              <a:t>17</a:t>
             </a:fld>
             <a:endParaRPr lang="en-US"/>
           </a:p>

</xml_diff>